<commit_message>
Deck: anticipated-questions appendix + objection speaker notes (stewardship lead, privacy shield, whose-app, why-annual)
</commit_message>
<xml_diff>
--- a/WBYC-Rangefinder-Pitch.pptx
+++ b/WBYC-Rangefinder-Pitch.pptx
@@ -17,9 +17,10 @@
     <p:sldId id="265" r:id="rId11"/>
     <p:sldId id="266" r:id="rId12"/>
     <p:sldId id="267" r:id="rId13"/>
+    <p:sldId id="268" r:id="rId14"/>
   </p:sldIdLst>
   <p:notesMasterIdLst>
-    <p:notesMasterId r:id="rId14"/>
+    <p:notesMasterId r:id="rId15"/>
   </p:notesMasterIdLst>
   <p:sldSz cx="12192000" cy="6858000"/>
   <p:notesSz cx="6858000" cy="12192000"/>
@@ -777,7 +778,7 @@
           <a:p>
             <a:r>
               <a:rPr lang="en-US" dirty="0"/>
-              <a:t>Close by offering a live demo round with the membership committee.</a:t>
+              <a:t>Lead with the stewardship line before taking questions. The data answer is a shield, not the pitch — use it only when liability comes up.</a:t>
             </a:r>
             <a:endParaRPr lang="en-US" dirty="0"/>
           </a:p>
@@ -801,6 +802,94 @@
             <a:fld id="{F7021451-1387-4CA6-816F-3879F97B5CBC}" type="slidenum">
               <a:rPr lang="en-US"/>
               <a:t>12</a:t>
+            </a:fld>
+            <a:endParaRPr lang="en-US"/>
+          </a:p>
+        </p:txBody>
+      </p:sp>
+    </p:spTree>
+    <p:extLst>
+      <p:ext uri="{BB962C8B-B14F-4D97-AF65-F5344CB8AC3E}">
+        <p14:creationId xmlns:p14="http://schemas.microsoft.com/office/powerpoint/2010/main" val="1024086991"/>
+      </p:ext>
+    </p:extLst>
+  </p:cSld>
+  <p:clrMapOvr>
+    <a:masterClrMapping/>
+  </p:clrMapOvr>
+</p:notes>
+</file>
+
+<file path=ppt/notesSlides/notesSlide13.xml><?xml version="1.0" encoding="utf-8"?>
+<p:notes xmlns:a="http://schemas.openxmlformats.org/drawingml/2006/main" xmlns:r="http://schemas.openxmlformats.org/officeDocument/2006/relationships" xmlns:p="http://schemas.openxmlformats.org/presentationml/2006/main">
+  <p:cSld>
+    <p:spTree>
+      <p:nvGrpSpPr>
+        <p:cNvPr id="1" name=""/>
+        <p:cNvGrpSpPr/>
+        <p:nvPr/>
+      </p:nvGrpSpPr>
+      <p:grpSpPr>
+        <a:xfrm>
+          <a:off x="0" y="0"/>
+          <a:ext cx="0" cy="0"/>
+          <a:chOff x="0" y="0"/>
+          <a:chExt cx="0" cy="0"/>
+        </a:xfrm>
+      </p:grpSpPr>
+      <p:sp>
+        <p:nvSpPr>
+          <p:cNvPr id="2" name="Slide Image Placeholder 1"/>
+          <p:cNvSpPr>
+            <a:spLocks noGrp="1" noRot="1" noChangeAspect="1"/>
+          </p:cNvSpPr>
+          <p:nvPr>
+            <p:ph type="sldImg"/>
+          </p:nvPr>
+        </p:nvSpPr>
+        <p:spPr/>
+      </p:sp>
+      <p:sp>
+        <p:nvSpPr>
+          <p:cNvPr id="3" name="Notes Placeholder 2"/>
+          <p:cNvSpPr>
+            <a:spLocks noGrp="1"/>
+          </p:cNvSpPr>
+          <p:nvPr>
+            <p:ph type="body" idx="1"/>
+          </p:nvPr>
+        </p:nvSpPr>
+        <p:spPr/>
+        <p:txBody>
+          <a:bodyPr/>
+          <a:lstStyle/>
+          <a:p>
+            <a:r>
+              <a:rPr lang="en-US" dirty="0"/>
+              <a:t>Close by offering a live demo round with the membership committee.</a:t>
+            </a:r>
+            <a:endParaRPr lang="en-US" dirty="0"/>
+          </a:p>
+        </p:txBody>
+      </p:sp>
+      <p:sp>
+        <p:nvSpPr>
+          <p:cNvPr id="4" name="Slide Number Placeholder 3"/>
+          <p:cNvSpPr>
+            <a:spLocks noGrp="1"/>
+          </p:cNvSpPr>
+          <p:nvPr>
+            <p:ph type="sldNum" sz="quarter" idx="10"/>
+          </p:nvPr>
+        </p:nvSpPr>
+        <p:spPr/>
+        <p:txBody>
+          <a:bodyPr/>
+          <a:lstStyle/>
+          <a:p>
+            <a:fld id="{F7021451-1387-4CA6-816F-3879F97B5CBC}" type="slidenum">
+              <a:rPr lang="en-US"/>
+              <a:t>13</a:t>
             </a:fld>
             <a:endParaRPr lang="en-US"/>
           </a:p>
@@ -865,7 +954,7 @@
           <a:p>
             <a:r>
               <a:rPr lang="en-US" dirty="0"/>
-              <a:t/>
+              <a:t>If "too much detail" comes up: the home screen is three big numbers, like the sprinkler heads. Everything else is opt-in taps. It passes the grandparent test on the first tee.</a:t>
             </a:r>
             <a:endParaRPr lang="en-US" dirty="0"/>
           </a:p>
@@ -1217,7 +1306,7 @@
           <a:p>
             <a:r>
               <a:rPr lang="en-US" dirty="0"/>
-              <a:t/>
+              <a:t>The "who cares" answer lives here: members are already using outside golf apps on our fairways — paying for them, and feeding them location data. The question is not whether an app is used at WBYC; it is whose.</a:t>
             </a:r>
             <a:endParaRPr lang="en-US" dirty="0"/>
           </a:p>
@@ -1481,7 +1570,7 @@
           <a:p>
             <a:r>
               <a:rPr lang="en-US" dirty="0"/>
-              <a:t/>
+              <a:t>If asked "why not one-time?": a one-time sale hands the club a depreciating asset; the annual trade buys a living service — seasonal re-survey, fixes, roadmap — and the ask sits below the $18K/yr member-value ceiling. Either side can walk at renewal.</a:t>
             </a:r>
             <a:endParaRPr lang="en-US" dirty="0"/>
           </a:p>
@@ -3608,6 +3697,575 @@
   <p:cSld name="Slide 12">
     <p:bg>
       <p:bgPr>
+        <a:solidFill>
+          <a:srgbClr val="F4FBF6"/>
+        </a:solidFill>
+      </p:bgPr>
+    </p:bg>
+    <p:spTree>
+      <p:nvGrpSpPr>
+        <p:cNvPr id="1" name=""/>
+        <p:cNvGrpSpPr/>
+        <p:nvPr/>
+      </p:nvGrpSpPr>
+      <p:grpSpPr>
+        <a:xfrm>
+          <a:off x="0" y="0"/>
+          <a:ext cx="0" cy="0"/>
+          <a:chOff x="0" y="0"/>
+          <a:chExt cx="0" cy="0"/>
+        </a:xfrm>
+      </p:grpSpPr>
+      <p:sp>
+        <p:nvSpPr>
+          <p:cNvPr id="2" name="Text 0"/>
+          <p:cNvSpPr/>
+          <p:nvPr/>
+        </p:nvSpPr>
+        <p:spPr>
+          <a:xfrm>
+            <a:off x="502920" y="384048"/>
+            <a:ext cx="9144000" cy="685800"/>
+          </a:xfrm>
+          <a:prstGeom prst="rect">
+            <a:avLst/>
+          </a:prstGeom>
+          <a:noFill/>
+          <a:ln/>
+        </p:spPr>
+        <p:txBody>
+          <a:bodyPr wrap="square" lIns="0" tIns="0" rIns="0" bIns="0" rtlCol="0" anchor="ctr"/>
+          <a:lstStyle/>
+          <a:p>
+            <a:pPr indent="0" marL="0">
+              <a:buNone/>
+            </a:pPr>
+            <a:r>
+              <a:rPr lang="en-US" sz="3600" b="1" dirty="0">
+                <a:solidFill>
+                  <a:srgbClr val="0E2A1C"/>
+                </a:solidFill>
+                <a:latin typeface="Didot" pitchFamily="34" charset="0"/>
+                <a:ea typeface="Didot" pitchFamily="34" charset="-122"/>
+                <a:cs typeface="Didot" pitchFamily="34" charset="-120"/>
+              </a:rPr>
+              <a:t>Anticipated questions</a:t>
+            </a:r>
+            <a:endParaRPr lang="en-US" sz="3600" dirty="0"/>
+          </a:p>
+        </p:txBody>
+      </p:sp>
+      <p:sp>
+        <p:nvSpPr>
+          <p:cNvPr id="3" name="Text 1"/>
+          <p:cNvSpPr/>
+          <p:nvPr/>
+        </p:nvSpPr>
+        <p:spPr>
+          <a:xfrm>
+            <a:off x="521208" y="1078992"/>
+            <a:ext cx="10607040" cy="365760"/>
+          </a:xfrm>
+          <a:prstGeom prst="rect">
+            <a:avLst/>
+          </a:prstGeom>
+          <a:noFill/>
+          <a:ln/>
+        </p:spPr>
+        <p:txBody>
+          <a:bodyPr wrap="square" lIns="0" tIns="0" rIns="0" bIns="0" rtlCol="0" anchor="ctr"/>
+          <a:lstStyle/>
+          <a:p>
+            <a:pPr indent="0" marL="0">
+              <a:buNone/>
+            </a:pPr>
+            <a:r>
+              <a:rPr lang="en-US" sz="1450" i="1" dirty="0">
+                <a:solidFill>
+                  <a:srgbClr val="5F7468"/>
+                </a:solidFill>
+                <a:latin typeface="Raleway" pitchFamily="34" charset="0"/>
+                <a:ea typeface="Raleway" pitchFamily="34" charset="-122"/>
+                <a:cs typeface="Raleway" pitchFamily="34" charset="-120"/>
+              </a:rPr>
+              <a:t>This is a stewardship project — the Ross course documented to two feet. A yardage book that happens to fit in a pocket.</a:t>
+            </a:r>
+            <a:endParaRPr lang="en-US" sz="1450" dirty="0"/>
+          </a:p>
+        </p:txBody>
+      </p:sp>
+      <p:sp>
+        <p:nvSpPr>
+          <p:cNvPr id="4" name="Shape 2"/>
+          <p:cNvSpPr/>
+          <p:nvPr/>
+        </p:nvSpPr>
+        <p:spPr>
+          <a:xfrm>
+            <a:off x="502920" y="1691640"/>
+            <a:ext cx="5376672" cy="1920240"/>
+          </a:xfrm>
+          <a:prstGeom prst="roundRect">
+            <a:avLst>
+              <a:gd name="adj" fmla="val 6667"/>
+            </a:avLst>
+          </a:prstGeom>
+          <a:solidFill>
+            <a:srgbClr val="FFFFFF"/>
+          </a:solidFill>
+          <a:ln w="12700">
+            <a:solidFill>
+              <a:srgbClr val="D5E8DC"/>
+            </a:solidFill>
+            <a:prstDash val="solid"/>
+          </a:ln>
+        </p:spPr>
+      </p:sp>
+      <p:sp>
+        <p:nvSpPr>
+          <p:cNvPr id="5" name="Text 3"/>
+          <p:cNvSpPr/>
+          <p:nvPr/>
+        </p:nvSpPr>
+        <p:spPr>
+          <a:xfrm>
+            <a:off x="777240" y="1874520"/>
+            <a:ext cx="4846320" cy="502920"/>
+          </a:xfrm>
+          <a:prstGeom prst="rect">
+            <a:avLst/>
+          </a:prstGeom>
+          <a:noFill/>
+          <a:ln/>
+        </p:spPr>
+        <p:txBody>
+          <a:bodyPr wrap="square" lIns="0" tIns="0" rIns="0" bIns="0" rtlCol="0" anchor="ctr"/>
+          <a:lstStyle/>
+          <a:p>
+            <a:pPr indent="0" marL="0">
+              <a:buNone/>
+            </a:pPr>
+            <a:r>
+              <a:rPr lang="en-US" sz="1450" b="1" i="1" dirty="0">
+                <a:solidFill>
+                  <a:srgbClr val="1E7A4A"/>
+                </a:solidFill>
+                <a:latin typeface="Didot" pitchFamily="34" charset="0"/>
+                <a:ea typeface="Didot" pitchFamily="34" charset="-122"/>
+                <a:cs typeface="Didot" pitchFamily="34" charset="-120"/>
+              </a:rPr>
+              <a:t>“Isn’t this too much detail for a traditional club?”</a:t>
+            </a:r>
+            <a:endParaRPr lang="en-US" sz="1450" dirty="0"/>
+          </a:p>
+        </p:txBody>
+      </p:sp>
+      <p:sp>
+        <p:nvSpPr>
+          <p:cNvPr id="6" name="Text 4"/>
+          <p:cNvSpPr/>
+          <p:nvPr/>
+        </p:nvSpPr>
+        <p:spPr>
+          <a:xfrm>
+            <a:off x="777240" y="2404872"/>
+            <a:ext cx="4846320" cy="1097280"/>
+          </a:xfrm>
+          <a:prstGeom prst="rect">
+            <a:avLst/>
+          </a:prstGeom>
+          <a:noFill/>
+          <a:ln/>
+        </p:spPr>
+        <p:txBody>
+          <a:bodyPr wrap="square" lIns="0" tIns="0" rIns="0" bIns="0" rtlCol="0" anchor="ctr"/>
+          <a:lstStyle/>
+          <a:p>
+            <a:pPr indent="0" marL="0">
+              <a:buNone/>
+            </a:pPr>
+            <a:r>
+              <a:rPr lang="en-US" sz="1100" dirty="0">
+                <a:solidFill>
+                  <a:srgbClr val="33463C"/>
+                </a:solidFill>
+                <a:latin typeface="Raleway" pitchFamily="34" charset="0"/>
+                <a:ea typeface="Raleway" pitchFamily="34" charset="-122"/>
+                <a:cs typeface="Raleway" pitchFamily="34" charset="-120"/>
+              </a:rPr>
+              <a:t>The front page is three big numbers — front, center, back — same as the sprinkler heads. Every layer beyond that is optional and waits for a tap. Clubs commission yardage books and course portraits without blinking; this is both.</a:t>
+            </a:r>
+            <a:endParaRPr lang="en-US" sz="1100" dirty="0"/>
+          </a:p>
+        </p:txBody>
+      </p:sp>
+      <p:sp>
+        <p:nvSpPr>
+          <p:cNvPr id="7" name="Shape 5"/>
+          <p:cNvSpPr/>
+          <p:nvPr/>
+        </p:nvSpPr>
+        <p:spPr>
+          <a:xfrm>
+            <a:off x="6309360" y="1691640"/>
+            <a:ext cx="5376672" cy="1920240"/>
+          </a:xfrm>
+          <a:prstGeom prst="roundRect">
+            <a:avLst>
+              <a:gd name="adj" fmla="val 6667"/>
+            </a:avLst>
+          </a:prstGeom>
+          <a:solidFill>
+            <a:srgbClr val="FFFFFF"/>
+          </a:solidFill>
+          <a:ln w="12700">
+            <a:solidFill>
+              <a:srgbClr val="D5E8DC"/>
+            </a:solidFill>
+            <a:prstDash val="solid"/>
+          </a:ln>
+        </p:spPr>
+      </p:sp>
+      <p:sp>
+        <p:nvSpPr>
+          <p:cNvPr id="8" name="Text 6"/>
+          <p:cNvSpPr/>
+          <p:nvPr/>
+        </p:nvSpPr>
+        <p:spPr>
+          <a:xfrm>
+            <a:off x="6583680" y="1874520"/>
+            <a:ext cx="4846320" cy="502920"/>
+          </a:xfrm>
+          <a:prstGeom prst="rect">
+            <a:avLst/>
+          </a:prstGeom>
+          <a:noFill/>
+          <a:ln/>
+        </p:spPr>
+        <p:txBody>
+          <a:bodyPr wrap="square" lIns="0" tIns="0" rIns="0" bIns="0" rtlCol="0" anchor="ctr"/>
+          <a:lstStyle/>
+          <a:p>
+            <a:pPr indent="0" marL="0">
+              <a:buNone/>
+            </a:pPr>
+            <a:r>
+              <a:rPr lang="en-US" sz="1450" b="1" i="1" dirty="0">
+                <a:solidFill>
+                  <a:srgbClr val="F000C2"/>
+                </a:solidFill>
+                <a:latin typeface="Didot" pitchFamily="34" charset="0"/>
+                <a:ea typeface="Didot" pitchFamily="34" charset="-122"/>
+                <a:cs typeface="Didot" pitchFamily="34" charset="-120"/>
+              </a:rPr>
+              <a:t>“Who cares? Will anyone actually use it?”</a:t>
+            </a:r>
+            <a:endParaRPr lang="en-US" sz="1450" dirty="0"/>
+          </a:p>
+        </p:txBody>
+      </p:sp>
+      <p:sp>
+        <p:nvSpPr>
+          <p:cNvPr id="9" name="Text 7"/>
+          <p:cNvSpPr/>
+          <p:nvPr/>
+        </p:nvSpPr>
+        <p:spPr>
+          <a:xfrm>
+            <a:off x="6583680" y="2404872"/>
+            <a:ext cx="4846320" cy="1097280"/>
+          </a:xfrm>
+          <a:prstGeom prst="rect">
+            <a:avLst/>
+          </a:prstGeom>
+          <a:noFill/>
+          <a:ln/>
+        </p:spPr>
+        <p:txBody>
+          <a:bodyPr wrap="square" lIns="0" tIns="0" rIns="0" bIns="0" rtlCol="0" anchor="ctr"/>
+          <a:lstStyle/>
+          <a:p>
+            <a:pPr indent="0" marL="0">
+              <a:buNone/>
+            </a:pPr>
+            <a:r>
+              <a:rPr lang="en-US" sz="1100" dirty="0">
+                <a:solidFill>
+                  <a:srgbClr val="33463C"/>
+                </a:solidFill>
+                <a:latin typeface="Raleway" pitchFamily="34" charset="0"/>
+                <a:ea typeface="Raleway" pitchFamily="34" charset="-122"/>
+                <a:cs typeface="Raleway" pitchFamily="34" charset="-120"/>
+              </a:rPr>
+              <a:t>Members already do — on our fairways, today, paying $60–100/yr to outside apps for fuzzy generic maps that harvest their location. The club can’t stop that. The only open question is whether the default app at WBYC is a stranger’s or the club’s own.</a:t>
+            </a:r>
+            <a:endParaRPr lang="en-US" sz="1100" dirty="0"/>
+          </a:p>
+        </p:txBody>
+      </p:sp>
+      <p:sp>
+        <p:nvSpPr>
+          <p:cNvPr id="10" name="Shape 8"/>
+          <p:cNvSpPr/>
+          <p:nvPr/>
+        </p:nvSpPr>
+        <p:spPr>
+          <a:xfrm>
+            <a:off x="502920" y="3840480"/>
+            <a:ext cx="5376672" cy="1920240"/>
+          </a:xfrm>
+          <a:prstGeom prst="roundRect">
+            <a:avLst>
+              <a:gd name="adj" fmla="val 6667"/>
+            </a:avLst>
+          </a:prstGeom>
+          <a:solidFill>
+            <a:srgbClr val="FFFFFF"/>
+          </a:solidFill>
+          <a:ln w="12700">
+            <a:solidFill>
+              <a:srgbClr val="D5E8DC"/>
+            </a:solidFill>
+            <a:prstDash val="solid"/>
+          </a:ln>
+        </p:spPr>
+      </p:sp>
+      <p:sp>
+        <p:nvSpPr>
+          <p:cNvPr id="11" name="Text 9"/>
+          <p:cNvSpPr/>
+          <p:nvPr/>
+        </p:nvSpPr>
+        <p:spPr>
+          <a:xfrm>
+            <a:off x="777240" y="4023360"/>
+            <a:ext cx="4846320" cy="502920"/>
+          </a:xfrm>
+          <a:prstGeom prst="rect">
+            <a:avLst/>
+          </a:prstGeom>
+          <a:noFill/>
+          <a:ln/>
+        </p:spPr>
+        <p:txBody>
+          <a:bodyPr wrap="square" lIns="0" tIns="0" rIns="0" bIns="0" rtlCol="0" anchor="ctr"/>
+          <a:lstStyle/>
+          <a:p>
+            <a:pPr indent="0" marL="0">
+              <a:buNone/>
+            </a:pPr>
+            <a:r>
+              <a:rPr lang="en-US" sz="1450" b="1" i="1" dirty="0">
+                <a:solidFill>
+                  <a:srgbClr val="1E7A4A"/>
+                </a:solidFill>
+                <a:latin typeface="Didot" pitchFamily="34" charset="0"/>
+                <a:ea typeface="Didot" pitchFamily="34" charset="-122"/>
+                <a:cs typeface="Didot" pitchFamily="34" charset="-120"/>
+              </a:rPr>
+              <a:t>“What about member data?”</a:t>
+            </a:r>
+            <a:endParaRPr lang="en-US" sz="1450" dirty="0"/>
+          </a:p>
+        </p:txBody>
+      </p:sp>
+      <p:sp>
+        <p:nvSpPr>
+          <p:cNvPr id="12" name="Text 10"/>
+          <p:cNvSpPr/>
+          <p:nvPr/>
+        </p:nvSpPr>
+        <p:spPr>
+          <a:xfrm>
+            <a:off x="777240" y="4553712"/>
+            <a:ext cx="4846320" cy="1097280"/>
+          </a:xfrm>
+          <a:prstGeom prst="rect">
+            <a:avLst/>
+          </a:prstGeom>
+          <a:noFill/>
+          <a:ln/>
+        </p:spPr>
+        <p:txBody>
+          <a:bodyPr wrap="square" lIns="0" tIns="0" rIns="0" bIns="0" rtlCol="0" anchor="ctr"/>
+          <a:lstStyle/>
+          <a:p>
+            <a:pPr indent="0" marL="0">
+              <a:buNone/>
+            </a:pPr>
+            <a:r>
+              <a:rPr lang="en-US" sz="1100" dirty="0">
+                <a:solidFill>
+                  <a:srgbClr val="33463C"/>
+                </a:solidFill>
+                <a:latin typeface="Raleway" pitchFamily="34" charset="0"/>
+                <a:ea typeface="Raleway" pitchFamily="34" charset="-122"/>
+                <a:cs typeface="Raleway" pitchFamily="34" charset="-120"/>
+              </a:rPr>
+              <a:t>There is none. No accounts, no sign-up, no analytics; rounds live on the member’s own phone and nothing leaves it. That is less data liability than any vendor app the club could buy.</a:t>
+            </a:r>
+            <a:endParaRPr lang="en-US" sz="1100" dirty="0"/>
+          </a:p>
+        </p:txBody>
+      </p:sp>
+      <p:sp>
+        <p:nvSpPr>
+          <p:cNvPr id="13" name="Shape 11"/>
+          <p:cNvSpPr/>
+          <p:nvPr/>
+        </p:nvSpPr>
+        <p:spPr>
+          <a:xfrm>
+            <a:off x="6309360" y="3840480"/>
+            <a:ext cx="5376672" cy="1920240"/>
+          </a:xfrm>
+          <a:prstGeom prst="roundRect">
+            <a:avLst>
+              <a:gd name="adj" fmla="val 6667"/>
+            </a:avLst>
+          </a:prstGeom>
+          <a:solidFill>
+            <a:srgbClr val="FFFFFF"/>
+          </a:solidFill>
+          <a:ln w="12700">
+            <a:solidFill>
+              <a:srgbClr val="D5E8DC"/>
+            </a:solidFill>
+            <a:prstDash val="solid"/>
+          </a:ln>
+        </p:spPr>
+      </p:sp>
+      <p:sp>
+        <p:nvSpPr>
+          <p:cNvPr id="14" name="Text 12"/>
+          <p:cNvSpPr/>
+          <p:nvPr/>
+        </p:nvSpPr>
+        <p:spPr>
+          <a:xfrm>
+            <a:off x="6583680" y="4023360"/>
+            <a:ext cx="4846320" cy="502920"/>
+          </a:xfrm>
+          <a:prstGeom prst="rect">
+            <a:avLst/>
+          </a:prstGeom>
+          <a:noFill/>
+          <a:ln/>
+        </p:spPr>
+        <p:txBody>
+          <a:bodyPr wrap="square" lIns="0" tIns="0" rIns="0" bIns="0" rtlCol="0" anchor="ctr"/>
+          <a:lstStyle/>
+          <a:p>
+            <a:pPr indent="0" marL="0">
+              <a:buNone/>
+            </a:pPr>
+            <a:r>
+              <a:rPr lang="en-US" sz="1450" b="1" i="1" dirty="0">
+                <a:solidFill>
+                  <a:srgbClr val="1E7A4A"/>
+                </a:solidFill>
+                <a:latin typeface="Didot" pitchFamily="34" charset="0"/>
+                <a:ea typeface="Didot" pitchFamily="34" charset="-122"/>
+                <a:cs typeface="Didot" pitchFamily="34" charset="-120"/>
+              </a:rPr>
+              <a:t>“Why annual, not one-time?”</a:t>
+            </a:r>
+            <a:endParaRPr lang="en-US" sz="1450" dirty="0"/>
+          </a:p>
+        </p:txBody>
+      </p:sp>
+      <p:sp>
+        <p:nvSpPr>
+          <p:cNvPr id="15" name="Text 13"/>
+          <p:cNvSpPr/>
+          <p:nvPr/>
+        </p:nvSpPr>
+        <p:spPr>
+          <a:xfrm>
+            <a:off x="6583680" y="4553712"/>
+            <a:ext cx="4846320" cy="1097280"/>
+          </a:xfrm>
+          <a:prstGeom prst="rect">
+            <a:avLst/>
+          </a:prstGeom>
+          <a:noFill/>
+          <a:ln/>
+        </p:spPr>
+        <p:txBody>
+          <a:bodyPr wrap="square" lIns="0" tIns="0" rIns="0" bIns="0" rtlCol="0" anchor="ctr"/>
+          <a:lstStyle/>
+          <a:p>
+            <a:pPr indent="0" marL="0">
+              <a:buNone/>
+            </a:pPr>
+            <a:r>
+              <a:rPr lang="en-US" sz="1100" dirty="0">
+                <a:solidFill>
+                  <a:srgbClr val="33463C"/>
+                </a:solidFill>
+                <a:latin typeface="Raleway" pitchFamily="34" charset="0"/>
+                <a:ea typeface="Raleway" pitchFamily="34" charset="-122"/>
+                <a:cs typeface="Raleway" pitchFamily="34" charset="-120"/>
+              </a:rPr>
+              <a:t>Because it’s a living service, not a purchase: greens re-surveyed each season, fixes within days, a roadmap the club steers. Renewal is annual and either side can walk — the club never holds a depreciating asset.</a:t>
+            </a:r>
+            <a:endParaRPr lang="en-US" sz="1100" dirty="0"/>
+          </a:p>
+        </p:txBody>
+      </p:sp>
+      <p:sp>
+        <p:nvSpPr>
+          <p:cNvPr id="17" name="Text 14"/>
+          <p:cNvSpPr/>
+          <p:nvPr/>
+        </p:nvSpPr>
+        <p:spPr>
+          <a:xfrm>
+            <a:off x="502920" y="6473952"/>
+            <a:ext cx="5486400" cy="274320"/>
+          </a:xfrm>
+          <a:prstGeom prst="rect">
+            <a:avLst/>
+          </a:prstGeom>
+          <a:noFill/>
+          <a:ln/>
+        </p:spPr>
+        <p:txBody>
+          <a:bodyPr wrap="square" lIns="0" tIns="0" rIns="0" bIns="0" rtlCol="0" anchor="ctr"/>
+          <a:lstStyle/>
+          <a:p>
+            <a:pPr indent="0" marL="0">
+              <a:buNone/>
+            </a:pPr>
+            <a:r>
+              <a:rPr lang="en-US" sz="900" dirty="0">
+                <a:solidFill>
+                  <a:srgbClr val="5F7468"/>
+                </a:solidFill>
+                <a:latin typeface="Raleway" pitchFamily="34" charset="0"/>
+                <a:ea typeface="Raleway" pitchFamily="34" charset="-122"/>
+                <a:cs typeface="Raleway" pitchFamily="34" charset="-120"/>
+              </a:rPr>
+              <a:t>WBYC Rangefinder · a member-built proposal · 12</a:t>
+            </a:r>
+            <a:endParaRPr lang="en-US" sz="900" dirty="0"/>
+          </a:p>
+        </p:txBody>
+      </p:sp>
+    </p:spTree>
+  </p:cSld>
+  <p:clrMapOvr>
+    <a:masterClrMapping/>
+  </p:clrMapOvr>
+</p:sld>
+</file>
+
+<file path=ppt/slides/slide13.xml><?xml version="1.0" encoding="utf-8"?>
+<p:sld xmlns:a="http://schemas.openxmlformats.org/drawingml/2006/main" xmlns:r="http://schemas.openxmlformats.org/officeDocument/2006/relationships" xmlns:p="http://schemas.openxmlformats.org/presentationml/2006/main">
+  <p:cSld name="Slide 13">
+    <p:bg>
+      <p:bgPr>
         <a:blipFill dpi="0" rotWithShape="1">
           <a:blip r:embed="rId1">
             <a:lum/>
@@ -4757,7 +5415,7 @@
       </p:sp>
       <p:sp>
         <p:nvSpPr>
-          <p:cNvPr id="29" name="Text 27"/>
+          <p:cNvPr id="30" name="Text 27"/>
           <p:cNvSpPr/>
           <p:nvPr/>
         </p:nvSpPr>
@@ -7861,7 +8519,7 @@
       </p:sp>
       <p:sp>
         <p:nvSpPr>
-          <p:cNvPr id="15" name="Text 13"/>
+          <p:cNvPr id="16" name="Text 13"/>
           <p:cNvSpPr/>
           <p:nvPr/>
         </p:nvSpPr>
@@ -9472,7 +10130,7 @@
       </p:sp>
       <p:sp>
         <p:nvSpPr>
-          <p:cNvPr id="10" name="Text 8"/>
+          <p:cNvPr id="11" name="Text 8"/>
           <p:cNvSpPr/>
           <p:nvPr/>
         </p:nvSpPr>

</xml_diff>

<commit_message>
Deck: full feature inventory appendix (slide 13, 24 items, 3 columns)
</commit_message>
<xml_diff>
--- a/WBYC-Rangefinder-Pitch.pptx
+++ b/WBYC-Rangefinder-Pitch.pptx
@@ -18,9 +18,10 @@
     <p:sldId id="266" r:id="rId12"/>
     <p:sldId id="267" r:id="rId13"/>
     <p:sldId id="268" r:id="rId14"/>
+    <p:sldId id="269" r:id="rId15"/>
   </p:sldIdLst>
   <p:notesMasterIdLst>
-    <p:notesMasterId r:id="rId15"/>
+    <p:notesMasterId r:id="rId16"/>
   </p:notesMasterIdLst>
   <p:sldSz cx="12192000" cy="6858000"/>
   <p:notesSz cx="6858000" cy="12192000"/>
@@ -866,7 +867,7 @@
           <a:p>
             <a:r>
               <a:rPr lang="en-US" dirty="0"/>
-              <a:t>Close by offering a live demo round with the membership committee.</a:t>
+              <a:t/>
             </a:r>
             <a:endParaRPr lang="en-US" dirty="0"/>
           </a:p>
@@ -890,6 +891,94 @@
             <a:fld id="{F7021451-1387-4CA6-816F-3879F97B5CBC}" type="slidenum">
               <a:rPr lang="en-US"/>
               <a:t>13</a:t>
+            </a:fld>
+            <a:endParaRPr lang="en-US"/>
+          </a:p>
+        </p:txBody>
+      </p:sp>
+    </p:spTree>
+    <p:extLst>
+      <p:ext uri="{BB962C8B-B14F-4D97-AF65-F5344CB8AC3E}">
+        <p14:creationId xmlns:p14="http://schemas.microsoft.com/office/powerpoint/2010/main" val="1024086991"/>
+      </p:ext>
+    </p:extLst>
+  </p:cSld>
+  <p:clrMapOvr>
+    <a:masterClrMapping/>
+  </p:clrMapOvr>
+</p:notes>
+</file>
+
+<file path=ppt/notesSlides/notesSlide14.xml><?xml version="1.0" encoding="utf-8"?>
+<p:notes xmlns:a="http://schemas.openxmlformats.org/drawingml/2006/main" xmlns:r="http://schemas.openxmlformats.org/officeDocument/2006/relationships" xmlns:p="http://schemas.openxmlformats.org/presentationml/2006/main">
+  <p:cSld>
+    <p:spTree>
+      <p:nvGrpSpPr>
+        <p:cNvPr id="1" name=""/>
+        <p:cNvGrpSpPr/>
+        <p:nvPr/>
+      </p:nvGrpSpPr>
+      <p:grpSpPr>
+        <a:xfrm>
+          <a:off x="0" y="0"/>
+          <a:ext cx="0" cy="0"/>
+          <a:chOff x="0" y="0"/>
+          <a:chExt cx="0" cy="0"/>
+        </a:xfrm>
+      </p:grpSpPr>
+      <p:sp>
+        <p:nvSpPr>
+          <p:cNvPr id="2" name="Slide Image Placeholder 1"/>
+          <p:cNvSpPr>
+            <a:spLocks noGrp="1" noRot="1" noChangeAspect="1"/>
+          </p:cNvSpPr>
+          <p:nvPr>
+            <p:ph type="sldImg"/>
+          </p:nvPr>
+        </p:nvSpPr>
+        <p:spPr/>
+      </p:sp>
+      <p:sp>
+        <p:nvSpPr>
+          <p:cNvPr id="3" name="Notes Placeholder 2"/>
+          <p:cNvSpPr>
+            <a:spLocks noGrp="1"/>
+          </p:cNvSpPr>
+          <p:nvPr>
+            <p:ph type="body" idx="1"/>
+          </p:nvPr>
+        </p:nvSpPr>
+        <p:spPr/>
+        <p:txBody>
+          <a:bodyPr/>
+          <a:lstStyle/>
+          <a:p>
+            <a:r>
+              <a:rPr lang="en-US" dirty="0"/>
+              <a:t>Close by offering a live demo round with the membership committee.</a:t>
+            </a:r>
+            <a:endParaRPr lang="en-US" dirty="0"/>
+          </a:p>
+        </p:txBody>
+      </p:sp>
+      <p:sp>
+        <p:nvSpPr>
+          <p:cNvPr id="4" name="Slide Number Placeholder 3"/>
+          <p:cNvSpPr>
+            <a:spLocks noGrp="1"/>
+          </p:cNvSpPr>
+          <p:nvPr>
+            <p:ph type="sldNum" sz="quarter" idx="10"/>
+          </p:nvPr>
+        </p:nvSpPr>
+        <p:spPr/>
+        <p:txBody>
+          <a:bodyPr/>
+          <a:lstStyle/>
+          <a:p>
+            <a:fld id="{F7021451-1387-4CA6-816F-3879F97B5CBC}" type="slidenum">
+              <a:rPr lang="en-US"/>
+              <a:t>14</a:t>
             </a:fld>
             <a:endParaRPr lang="en-US"/>
           </a:p>
@@ -4264,6 +4353,881 @@
 <file path=ppt/slides/slide13.xml><?xml version="1.0" encoding="utf-8"?>
 <p:sld xmlns:a="http://schemas.openxmlformats.org/drawingml/2006/main" xmlns:r="http://schemas.openxmlformats.org/officeDocument/2006/relationships" xmlns:p="http://schemas.openxmlformats.org/presentationml/2006/main">
   <p:cSld name="Slide 13">
+    <p:bg>
+      <p:bgPr>
+        <a:solidFill>
+          <a:srgbClr val="FFFFFF"/>
+        </a:solidFill>
+      </p:bgPr>
+    </p:bg>
+    <p:spTree>
+      <p:nvGrpSpPr>
+        <p:cNvPr id="1" name=""/>
+        <p:cNvGrpSpPr/>
+        <p:nvPr/>
+      </p:nvGrpSpPr>
+      <p:grpSpPr>
+        <a:xfrm>
+          <a:off x="0" y="0"/>
+          <a:ext cx="0" cy="0"/>
+          <a:chOff x="0" y="0"/>
+          <a:chExt cx="0" cy="0"/>
+        </a:xfrm>
+      </p:grpSpPr>
+      <p:sp>
+        <p:nvSpPr>
+          <p:cNvPr id="2" name="Text 0"/>
+          <p:cNvSpPr/>
+          <p:nvPr/>
+        </p:nvSpPr>
+        <p:spPr>
+          <a:xfrm>
+            <a:off x="502920" y="384048"/>
+            <a:ext cx="9144000" cy="685800"/>
+          </a:xfrm>
+          <a:prstGeom prst="rect">
+            <a:avLst/>
+          </a:prstGeom>
+          <a:noFill/>
+          <a:ln/>
+        </p:spPr>
+        <p:txBody>
+          <a:bodyPr wrap="square" lIns="0" tIns="0" rIns="0" bIns="0" rtlCol="0" anchor="ctr"/>
+          <a:lstStyle/>
+          <a:p>
+            <a:pPr indent="0" marL="0">
+              <a:buNone/>
+            </a:pPr>
+            <a:r>
+              <a:rPr lang="en-US" sz="3600" b="1" dirty="0">
+                <a:solidFill>
+                  <a:srgbClr val="0E2A1C"/>
+                </a:solidFill>
+                <a:latin typeface="Didot" pitchFamily="34" charset="0"/>
+                <a:ea typeface="Didot" pitchFamily="34" charset="-122"/>
+                <a:cs typeface="Didot" pitchFamily="34" charset="-120"/>
+              </a:rPr>
+              <a:t>Appendix: the full inventory</a:t>
+            </a:r>
+            <a:endParaRPr lang="en-US" sz="3600" dirty="0"/>
+          </a:p>
+        </p:txBody>
+      </p:sp>
+      <p:sp>
+        <p:nvSpPr>
+          <p:cNvPr id="3" name="Text 1"/>
+          <p:cNvSpPr/>
+          <p:nvPr/>
+        </p:nvSpPr>
+        <p:spPr>
+          <a:xfrm>
+            <a:off x="521208" y="1078992"/>
+            <a:ext cx="10058400" cy="365760"/>
+          </a:xfrm>
+          <a:prstGeom prst="rect">
+            <a:avLst/>
+          </a:prstGeom>
+          <a:noFill/>
+          <a:ln/>
+        </p:spPr>
+        <p:txBody>
+          <a:bodyPr wrap="square" lIns="0" tIns="0" rIns="0" bIns="0" rtlCol="0" anchor="ctr"/>
+          <a:lstStyle/>
+          <a:p>
+            <a:pPr indent="0" marL="0">
+              <a:buNone/>
+            </a:pPr>
+            <a:r>
+              <a:rPr lang="en-US" sz="1450" i="1" dirty="0">
+                <a:solidFill>
+                  <a:srgbClr val="5F7468"/>
+                </a:solidFill>
+                <a:latin typeface="Raleway" pitchFamily="34" charset="0"/>
+                <a:ea typeface="Raleway" pitchFamily="34" charset="-122"/>
+                <a:cs typeface="Raleway" pitchFamily="34" charset="-120"/>
+              </a:rPr>
+              <a:t>Everything in the box today — the breadth a commissioned build would be quoted on.</a:t>
+            </a:r>
+            <a:endParaRPr lang="en-US" sz="1450" dirty="0"/>
+          </a:p>
+        </p:txBody>
+      </p:sp>
+      <p:sp>
+        <p:nvSpPr>
+          <p:cNvPr id="4" name="Text 2"/>
+          <p:cNvSpPr/>
+          <p:nvPr/>
+        </p:nvSpPr>
+        <p:spPr>
+          <a:xfrm>
+            <a:off x="502920" y="1645920"/>
+            <a:ext cx="3566160" cy="320040"/>
+          </a:xfrm>
+          <a:prstGeom prst="rect">
+            <a:avLst/>
+          </a:prstGeom>
+          <a:noFill/>
+          <a:ln/>
+        </p:spPr>
+        <p:txBody>
+          <a:bodyPr wrap="square" lIns="0" tIns="0" rIns="0" bIns="0" rtlCol="0" anchor="ctr"/>
+          <a:lstStyle/>
+          <a:p>
+            <a:pPr indent="0" marL="0">
+              <a:buNone/>
+            </a:pPr>
+            <a:r>
+              <a:rPr lang="en-US" sz="1200" b="1" spc="200" kern="0" dirty="0">
+                <a:solidFill>
+                  <a:srgbClr val="1E7A4A"/>
+                </a:solidFill>
+                <a:latin typeface="Raleway" pitchFamily="34" charset="0"/>
+                <a:ea typeface="Raleway" pitchFamily="34" charset="-122"/>
+                <a:cs typeface="Raleway" pitchFamily="34" charset="-120"/>
+              </a:rPr>
+              <a:t>ON THE COURSE</a:t>
+            </a:r>
+            <a:endParaRPr lang="en-US" sz="1200" dirty="0"/>
+          </a:p>
+        </p:txBody>
+      </p:sp>
+      <p:sp>
+        <p:nvSpPr>
+          <p:cNvPr id="5" name="Text 3"/>
+          <p:cNvSpPr/>
+          <p:nvPr/>
+        </p:nvSpPr>
+        <p:spPr>
+          <a:xfrm>
+            <a:off x="502920" y="2057400"/>
+            <a:ext cx="3611880" cy="4023360"/>
+          </a:xfrm>
+          <a:prstGeom prst="rect">
+            <a:avLst/>
+          </a:prstGeom>
+          <a:noFill/>
+          <a:ln/>
+        </p:spPr>
+        <p:txBody>
+          <a:bodyPr wrap="square" lIns="0" tIns="0" rIns="0" bIns="0" rtlCol="0" anchor="t"/>
+          <a:lstStyle/>
+          <a:p>
+            <a:pPr marL="127000" indent="-127000">
+              <a:spcAft>
+                <a:spcPts val="700"/>
+              </a:spcAft>
+              <a:buSzPct val="100000"/>
+              <a:buChar char="•"/>
+            </a:pPr>
+            <a:r>
+              <a:rPr lang="en-US" sz="1050" dirty="0">
+                <a:solidFill>
+                  <a:srgbClr val="33463C"/>
+                </a:solidFill>
+                <a:latin typeface="Raleway" pitchFamily="34" charset="0"/>
+                <a:ea typeface="Raleway" pitchFamily="34" charset="-122"/>
+                <a:cs typeface="Raleway" pitchFamily="34" charset="-120"/>
+              </a:rPr>
+              <a:t>Live GPS front / center / back, 5-fix smoothing</a:t>
+            </a:r>
+            <a:endParaRPr lang="en-US" sz="1050" dirty="0"/>
+          </a:p>
+          <a:p>
+            <a:pPr marL="127000" indent="-127000">
+              <a:spcAft>
+                <a:spcPts val="700"/>
+              </a:spcAft>
+              <a:buSzPct val="100000"/>
+              <a:buChar char="•"/>
+            </a:pPr>
+            <a:r>
+              <a:rPr lang="en-US" sz="1050" dirty="0">
+                <a:solidFill>
+                  <a:srgbClr val="33463C"/>
+                </a:solidFill>
+                <a:latin typeface="Raleway" pitchFamily="34" charset="0"/>
+                <a:ea typeface="Raleway" pitchFamily="34" charset="-122"/>
+                <a:cs typeface="Raleway" pitchFamily="34" charset="-120"/>
+              </a:rPr>
+              <a:t>“Plays like” — elevation + live or manual wind</a:t>
+            </a:r>
+            <a:endParaRPr lang="en-US" sz="1050" dirty="0"/>
+          </a:p>
+          <a:p>
+            <a:pPr marL="127000" indent="-127000">
+              <a:spcAft>
+                <a:spcPts val="700"/>
+              </a:spcAft>
+              <a:buSzPct val="100000"/>
+              <a:buChar char="•"/>
+            </a:pPr>
+            <a:r>
+              <a:rPr lang="en-US" sz="1050" dirty="0">
+                <a:solidFill>
+                  <a:srgbClr val="33463C"/>
+                </a:solidFill>
+                <a:latin typeface="Raleway" pitchFamily="34" charset="0"/>
+                <a:ea typeface="Raleway" pitchFamily="34" charset="-122"/>
+                <a:cs typeface="Raleway" pitchFamily="34" charset="-120"/>
+              </a:rPr>
+              <a:t>Per-hole wind arrow, oriented to the shot</a:t>
+            </a:r>
+            <a:endParaRPr lang="en-US" sz="1050" dirty="0"/>
+          </a:p>
+          <a:p>
+            <a:pPr marL="127000" indent="-127000">
+              <a:spcAft>
+                <a:spcPts val="700"/>
+              </a:spcAft>
+              <a:buSzPct val="100000"/>
+              <a:buChar char="•"/>
+            </a:pPr>
+            <a:r>
+              <a:rPr lang="en-US" sz="1050" dirty="0">
+                <a:solidFill>
+                  <a:srgbClr val="33463C"/>
+                </a:solidFill>
+                <a:latin typeface="Raleway" pitchFamily="34" charset="0"/>
+                <a:ea typeface="Raleway" pitchFamily="34" charset="-122"/>
+                <a:cs typeface="Raleway" pitchFamily="34" charset="-120"/>
+              </a:rPr>
+              <a:t>Hazards &amp; targets: reach/carry to every bunker, water, dogleg</a:t>
+            </a:r>
+            <a:endParaRPr lang="en-US" sz="1050" dirty="0"/>
+          </a:p>
+          <a:p>
+            <a:pPr marL="127000" indent="-127000">
+              <a:spcAft>
+                <a:spcPts val="700"/>
+              </a:spcAft>
+              <a:buSzPct val="100000"/>
+              <a:buChar char="•"/>
+            </a:pPr>
+            <a:r>
+              <a:rPr lang="en-US" sz="1050" dirty="0">
+                <a:solidFill>
+                  <a:srgbClr val="33463C"/>
+                </a:solidFill>
+                <a:latin typeface="Raleway" pitchFamily="34" charset="0"/>
+                <a:ea typeface="Raleway" pitchFamily="34" charset="-122"/>
+                <a:cs typeface="Raleway" pitchFamily="34" charset="-120"/>
+              </a:rPr>
+              <a:t>Carry arcs for the selected club ± neighbors</a:t>
+            </a:r>
+            <a:endParaRPr lang="en-US" sz="1050" dirty="0"/>
+          </a:p>
+          <a:p>
+            <a:pPr marL="127000" indent="-127000">
+              <a:spcAft>
+                <a:spcPts val="700"/>
+              </a:spcAft>
+              <a:buSzPct val="100000"/>
+              <a:buChar char="•"/>
+            </a:pPr>
+            <a:r>
+              <a:rPr lang="en-US" sz="1050" dirty="0">
+                <a:solidFill>
+                  <a:srgbClr val="33463C"/>
+                </a:solidFill>
+                <a:latin typeface="Raleway" pitchFamily="34" charset="0"/>
+                <a:ea typeface="Raleway" pitchFamily="34" charset="-122"/>
+                <a:cs typeface="Raleway" pitchFamily="34" charset="-120"/>
+              </a:rPr>
+              <a:t>Auto hole detection as you walk</a:t>
+            </a:r>
+            <a:endParaRPr lang="en-US" sz="1050" dirty="0"/>
+          </a:p>
+          <a:p>
+            <a:pPr marL="127000" indent="-127000">
+              <a:spcAft>
+                <a:spcPts val="700"/>
+              </a:spcAft>
+              <a:buSzPct val="100000"/>
+              <a:buChar char="•"/>
+            </a:pPr>
+            <a:r>
+              <a:rPr lang="en-US" sz="1050" dirty="0">
+                <a:solidFill>
+                  <a:srgbClr val="33463C"/>
+                </a:solidFill>
+                <a:latin typeface="Raleway" pitchFamily="34" charset="0"/>
+                <a:ea typeface="Raleway" pitchFamily="34" charset="-122"/>
+                <a:cs typeface="Raleway" pitchFamily="34" charset="-120"/>
+              </a:rPr>
+              <a:t>Ball-flight tracer: map arc, side profile, 3D flyover + stats</a:t>
+            </a:r>
+            <a:endParaRPr lang="en-US" sz="1050" dirty="0"/>
+          </a:p>
+          <a:p>
+            <a:pPr marL="127000" indent="-127000">
+              <a:spcAft>
+                <a:spcPts val="700"/>
+              </a:spcAft>
+              <a:buSzPct val="100000"/>
+              <a:buChar char="•"/>
+            </a:pPr>
+            <a:r>
+              <a:rPr lang="en-US" sz="1050" dirty="0">
+                <a:solidFill>
+                  <a:srgbClr val="33463C"/>
+                </a:solidFill>
+                <a:latin typeface="Raleway" pitchFamily="34" charset="0"/>
+                <a:ea typeface="Raleway" pitchFamily="34" charset="-122"/>
+                <a:cs typeface="Raleway" pitchFamily="34" charset="-120"/>
+              </a:rPr>
+              <a:t>Tournament switch: one tap to legal raw yardages</a:t>
+            </a:r>
+            <a:endParaRPr lang="en-US" sz="1050" dirty="0"/>
+          </a:p>
+        </p:txBody>
+      </p:sp>
+      <p:sp>
+        <p:nvSpPr>
+          <p:cNvPr id="6" name="Text 4"/>
+          <p:cNvSpPr/>
+          <p:nvPr/>
+        </p:nvSpPr>
+        <p:spPr>
+          <a:xfrm>
+            <a:off x="4325112" y="1645920"/>
+            <a:ext cx="3566160" cy="320040"/>
+          </a:xfrm>
+          <a:prstGeom prst="rect">
+            <a:avLst/>
+          </a:prstGeom>
+          <a:noFill/>
+          <a:ln/>
+        </p:spPr>
+        <p:txBody>
+          <a:bodyPr wrap="square" lIns="0" tIns="0" rIns="0" bIns="0" rtlCol="0" anchor="ctr"/>
+          <a:lstStyle/>
+          <a:p>
+            <a:pPr indent="0" marL="0">
+              <a:buNone/>
+            </a:pPr>
+            <a:r>
+              <a:rPr lang="en-US" sz="1200" b="1" spc="200" kern="0" dirty="0">
+                <a:solidFill>
+                  <a:srgbClr val="1E7A4A"/>
+                </a:solidFill>
+                <a:latin typeface="Raleway" pitchFamily="34" charset="0"/>
+                <a:ea typeface="Raleway" pitchFamily="34" charset="-122"/>
+                <a:cs typeface="Raleway" pitchFamily="34" charset="-120"/>
+              </a:rPr>
+              <a:t>SCORING &amp; YOUR GAME</a:t>
+            </a:r>
+            <a:endParaRPr lang="en-US" sz="1200" dirty="0"/>
+          </a:p>
+        </p:txBody>
+      </p:sp>
+      <p:sp>
+        <p:nvSpPr>
+          <p:cNvPr id="7" name="Text 5"/>
+          <p:cNvSpPr/>
+          <p:nvPr/>
+        </p:nvSpPr>
+        <p:spPr>
+          <a:xfrm>
+            <a:off x="4325112" y="2057400"/>
+            <a:ext cx="3611880" cy="4023360"/>
+          </a:xfrm>
+          <a:prstGeom prst="rect">
+            <a:avLst/>
+          </a:prstGeom>
+          <a:noFill/>
+          <a:ln/>
+        </p:spPr>
+        <p:txBody>
+          <a:bodyPr wrap="square" lIns="0" tIns="0" rIns="0" bIns="0" rtlCol="0" anchor="t"/>
+          <a:lstStyle/>
+          <a:p>
+            <a:pPr marL="127000" indent="-127000">
+              <a:spcAft>
+                <a:spcPts val="700"/>
+              </a:spcAft>
+              <a:buSzPct val="100000"/>
+              <a:buChar char="•"/>
+            </a:pPr>
+            <a:r>
+              <a:rPr lang="en-US" sz="1050" dirty="0">
+                <a:solidFill>
+                  <a:srgbClr val="33463C"/>
+                </a:solidFill>
+                <a:latin typeface="Raleway" pitchFamily="34" charset="0"/>
+                <a:ea typeface="Raleway" pitchFamily="34" charset="-122"/>
+                <a:cs typeface="Raleway" pitchFamily="34" charset="-120"/>
+              </a:rPr>
+              <a:t>Running strokes / putts / fairways strip</a:t>
+            </a:r>
+            <a:endParaRPr lang="en-US" sz="1050" dirty="0"/>
+          </a:p>
+          <a:p>
+            <a:pPr marL="127000" indent="-127000">
+              <a:spcAft>
+                <a:spcPts val="700"/>
+              </a:spcAft>
+              <a:buSzPct val="100000"/>
+              <a:buChar char="•"/>
+            </a:pPr>
+            <a:r>
+              <a:rPr lang="en-US" sz="1050" dirty="0">
+                <a:solidFill>
+                  <a:srgbClr val="33463C"/>
+                </a:solidFill>
+                <a:latin typeface="Raleway" pitchFamily="34" charset="0"/>
+                <a:ea typeface="Raleway" pitchFamily="34" charset="-122"/>
+                <a:cs typeface="Raleway" pitchFamily="34" charset="-120"/>
+              </a:rPr>
+              <a:t>Full 18-hole card with OUT/IN/total &amp; GIR</a:t>
+            </a:r>
+            <a:endParaRPr lang="en-US" sz="1050" dirty="0"/>
+          </a:p>
+          <a:p>
+            <a:pPr marL="127000" indent="-127000">
+              <a:spcAft>
+                <a:spcPts val="700"/>
+              </a:spcAft>
+              <a:buSzPct val="100000"/>
+              <a:buChar char="•"/>
+            </a:pPr>
+            <a:r>
+              <a:rPr lang="en-US" sz="1050" dirty="0">
+                <a:solidFill>
+                  <a:srgbClr val="33463C"/>
+                </a:solidFill>
+                <a:latin typeface="Raleway" pitchFamily="34" charset="0"/>
+                <a:ea typeface="Raleway" pitchFamily="34" charset="-122"/>
+                <a:cs typeface="Raleway" pitchFamily="34" charset="-120"/>
+              </a:rPr>
+              <a:t>Round history: trend line, bests, last-5 averages</a:t>
+            </a:r>
+            <a:endParaRPr lang="en-US" sz="1050" dirty="0"/>
+          </a:p>
+          <a:p>
+            <a:pPr marL="127000" indent="-127000">
+              <a:spcAft>
+                <a:spcPts val="700"/>
+              </a:spcAft>
+              <a:buSzPct val="100000"/>
+              <a:buChar char="•"/>
+            </a:pPr>
+            <a:r>
+              <a:rPr lang="en-US" sz="1050" dirty="0">
+                <a:solidFill>
+                  <a:srgbClr val="33463C"/>
+                </a:solidFill>
+                <a:latin typeface="Raleway" pitchFamily="34" charset="0"/>
+                <a:ea typeface="Raleway" pitchFamily="34" charset="-122"/>
+                <a:cs typeface="Raleway" pitchFamily="34" charset="-120"/>
+              </a:rPr>
+              <a:t>Club distances learned from marked shots</a:t>
+            </a:r>
+            <a:endParaRPr lang="en-US" sz="1050" dirty="0"/>
+          </a:p>
+          <a:p>
+            <a:pPr marL="127000" indent="-127000">
+              <a:spcAft>
+                <a:spcPts val="700"/>
+              </a:spcAft>
+              <a:buSzPct val="100000"/>
+              <a:buChar char="•"/>
+            </a:pPr>
+            <a:r>
+              <a:rPr lang="en-US" sz="1050" dirty="0">
+                <a:solidFill>
+                  <a:srgbClr val="33463C"/>
+                </a:solidFill>
+                <a:latin typeface="Raleway" pitchFamily="34" charset="0"/>
+                <a:ea typeface="Raleway" pitchFamily="34" charset="-122"/>
+                <a:cs typeface="Raleway" pitchFamily="34" charset="-120"/>
+              </a:rPr>
+              <a:t>Club hints inside the plays-like readout</a:t>
+            </a:r>
+            <a:endParaRPr lang="en-US" sz="1050" dirty="0"/>
+          </a:p>
+          <a:p>
+            <a:pPr marL="127000" indent="-127000">
+              <a:spcAft>
+                <a:spcPts val="700"/>
+              </a:spcAft>
+              <a:buSzPct val="100000"/>
+              <a:buChar char="•"/>
+            </a:pPr>
+            <a:r>
+              <a:rPr lang="en-US" sz="1050" dirty="0">
+                <a:solidFill>
+                  <a:srgbClr val="33463C"/>
+                </a:solidFill>
+                <a:latin typeface="Raleway" pitchFamily="34" charset="0"/>
+                <a:ea typeface="Raleway" pitchFamily="34" charset="-122"/>
+                <a:cs typeface="Raleway" pitchFamily="34" charset="-120"/>
+              </a:rPr>
+              <a:t>Shot map: numbered dots + trail per hole</a:t>
+            </a:r>
+            <a:endParaRPr lang="en-US" sz="1050" dirty="0"/>
+          </a:p>
+          <a:p>
+            <a:pPr marL="127000" indent="-127000">
+              <a:spcAft>
+                <a:spcPts val="700"/>
+              </a:spcAft>
+              <a:buSzPct val="100000"/>
+              <a:buChar char="•"/>
+            </a:pPr>
+            <a:r>
+              <a:rPr lang="en-US" sz="1050" dirty="0">
+                <a:solidFill>
+                  <a:srgbClr val="33463C"/>
+                </a:solidFill>
+                <a:latin typeface="Raleway" pitchFamily="34" charset="0"/>
+                <a:ea typeface="Raleway" pitchFamily="34" charset="-122"/>
+                <a:cs typeface="Raleway" pitchFamily="34" charset="-120"/>
+              </a:rPr>
+              <a:t>One-tap GHIN posting helper</a:t>
+            </a:r>
+            <a:endParaRPr lang="en-US" sz="1050" dirty="0"/>
+          </a:p>
+          <a:p>
+            <a:pPr marL="127000" indent="-127000">
+              <a:spcAft>
+                <a:spcPts val="700"/>
+              </a:spcAft>
+              <a:buSzPct val="100000"/>
+              <a:buChar char="•"/>
+            </a:pPr>
+            <a:r>
+              <a:rPr lang="en-US" sz="1050" dirty="0">
+                <a:solidFill>
+                  <a:srgbClr val="33463C"/>
+                </a:solidFill>
+                <a:latin typeface="Raleway" pitchFamily="34" charset="0"/>
+                <a:ea typeface="Raleway" pitchFamily="34" charset="-122"/>
+                <a:cs typeface="Raleway" pitchFamily="34" charset="-120"/>
+              </a:rPr>
+              <a:t>Women’s par handled automatically from the Red tees</a:t>
+            </a:r>
+            <a:endParaRPr lang="en-US" sz="1050" dirty="0"/>
+          </a:p>
+        </p:txBody>
+      </p:sp>
+      <p:sp>
+        <p:nvSpPr>
+          <p:cNvPr id="8" name="Text 6"/>
+          <p:cNvSpPr/>
+          <p:nvPr/>
+        </p:nvSpPr>
+        <p:spPr>
+          <a:xfrm>
+            <a:off x="8147304" y="1645920"/>
+            <a:ext cx="3566160" cy="320040"/>
+          </a:xfrm>
+          <a:prstGeom prst="rect">
+            <a:avLst/>
+          </a:prstGeom>
+          <a:noFill/>
+          <a:ln/>
+        </p:spPr>
+        <p:txBody>
+          <a:bodyPr wrap="square" lIns="0" tIns="0" rIns="0" bIns="0" rtlCol="0" anchor="ctr"/>
+          <a:lstStyle/>
+          <a:p>
+            <a:pPr indent="0" marL="0">
+              <a:buNone/>
+            </a:pPr>
+            <a:r>
+              <a:rPr lang="en-US" sz="1200" b="1" spc="200" kern="0" dirty="0">
+                <a:solidFill>
+                  <a:srgbClr val="F000C2"/>
+                </a:solidFill>
+                <a:latin typeface="Raleway" pitchFamily="34" charset="0"/>
+                <a:ea typeface="Raleway" pitchFamily="34" charset="-122"/>
+                <a:cs typeface="Raleway" pitchFamily="34" charset="-120"/>
+              </a:rPr>
+              <a:t>CRAFT &amp; PLATFORM</a:t>
+            </a:r>
+            <a:endParaRPr lang="en-US" sz="1200" dirty="0"/>
+          </a:p>
+        </p:txBody>
+      </p:sp>
+      <p:sp>
+        <p:nvSpPr>
+          <p:cNvPr id="9" name="Text 7"/>
+          <p:cNvSpPr/>
+          <p:nvPr/>
+        </p:nvSpPr>
+        <p:spPr>
+          <a:xfrm>
+            <a:off x="8147304" y="2057400"/>
+            <a:ext cx="3611880" cy="4023360"/>
+          </a:xfrm>
+          <a:prstGeom prst="rect">
+            <a:avLst/>
+          </a:prstGeom>
+          <a:noFill/>
+          <a:ln/>
+        </p:spPr>
+        <p:txBody>
+          <a:bodyPr wrap="square" lIns="0" tIns="0" rIns="0" bIns="0" rtlCol="0" anchor="t"/>
+          <a:lstStyle/>
+          <a:p>
+            <a:pPr marL="127000" indent="-127000">
+              <a:spcAft>
+                <a:spcPts val="700"/>
+              </a:spcAft>
+              <a:buSzPct val="100000"/>
+              <a:buChar char="•"/>
+            </a:pPr>
+            <a:r>
+              <a:rPr lang="en-US" sz="1050" dirty="0">
+                <a:solidFill>
+                  <a:srgbClr val="33463C"/>
+                </a:solidFill>
+                <a:latin typeface="Raleway" pitchFamily="34" charset="0"/>
+                <a:ea typeface="Raleway" pitchFamily="34" charset="-122"/>
+                <a:cs typeface="Raleway" pitchFamily="34" charset="-120"/>
+              </a:rPr>
+              <a:t>2-ft contours; fall-line arrows on every green</a:t>
+            </a:r>
+            <a:endParaRPr lang="en-US" sz="1050" dirty="0"/>
+          </a:p>
+          <a:p>
+            <a:pPr marL="127000" indent="-127000">
+              <a:spcAft>
+                <a:spcPts val="700"/>
+              </a:spcAft>
+              <a:buSzPct val="100000"/>
+              <a:buChar char="•"/>
+            </a:pPr>
+            <a:r>
+              <a:rPr lang="en-US" sz="1050" dirty="0">
+                <a:solidFill>
+                  <a:srgbClr val="33463C"/>
+                </a:solidFill>
+                <a:latin typeface="Raleway" pitchFamily="34" charset="0"/>
+                <a:ea typeface="Raleway" pitchFamily="34" charset="-122"/>
+                <a:cs typeface="Raleway" pitchFamily="34" charset="-120"/>
+              </a:rPr>
+              <a:t>Hypsometric terrain tint with hillshading</a:t>
+            </a:r>
+            <a:endParaRPr lang="en-US" sz="1050" dirty="0"/>
+          </a:p>
+          <a:p>
+            <a:pPr marL="127000" indent="-127000">
+              <a:spcAft>
+                <a:spcPts val="700"/>
+              </a:spcAft>
+              <a:buSzPct val="100000"/>
+              <a:buChar char="•"/>
+            </a:pPr>
+            <a:r>
+              <a:rPr lang="en-US" sz="1050" dirty="0">
+                <a:solidFill>
+                  <a:srgbClr val="33463C"/>
+                </a:solidFill>
+                <a:latin typeface="Raleway" pitchFamily="34" charset="0"/>
+                <a:ea typeface="Raleway" pitchFamily="34" charset="-122"/>
+                <a:cs typeface="Raleway" pitchFamily="34" charset="-120"/>
+              </a:rPr>
+              <a:t>NAIP aerial layer (SAT), geo-aligned</a:t>
+            </a:r>
+            <a:endParaRPr lang="en-US" sz="1050" dirty="0"/>
+          </a:p>
+          <a:p>
+            <a:pPr marL="127000" indent="-127000">
+              <a:spcAft>
+                <a:spcPts val="700"/>
+              </a:spcAft>
+              <a:buSzPct val="100000"/>
+              <a:buChar char="•"/>
+            </a:pPr>
+            <a:r>
+              <a:rPr lang="en-US" sz="1050" dirty="0">
+                <a:solidFill>
+                  <a:srgbClr val="33463C"/>
+                </a:solidFill>
+                <a:latin typeface="Raleway" pitchFamily="34" charset="0"/>
+                <a:ea typeface="Raleway" pitchFamily="34" charset="-122"/>
+                <a:cs typeface="Raleway" pitchFamily="34" charset="-120"/>
+              </a:rPr>
+              <a:t>3D terrain with adjustable exaggeration</a:t>
+            </a:r>
+            <a:endParaRPr lang="en-US" sz="1050" dirty="0"/>
+          </a:p>
+          <a:p>
+            <a:pPr marL="127000" indent="-127000">
+              <a:spcAft>
+                <a:spcPts val="700"/>
+              </a:spcAft>
+              <a:buSzPct val="100000"/>
+              <a:buChar char="•"/>
+            </a:pPr>
+            <a:r>
+              <a:rPr lang="en-US" sz="1050" dirty="0">
+                <a:solidFill>
+                  <a:srgbClr val="33463C"/>
+                </a:solidFill>
+                <a:latin typeface="Raleway" pitchFamily="34" charset="0"/>
+                <a:ea typeface="Raleway" pitchFamily="34" charset="-122"/>
+                <a:cs typeface="Raleway" pitchFamily="34" charset="-120"/>
+              </a:rPr>
+              <a:t>Three themes, incl. a bright-sunlight mode</a:t>
+            </a:r>
+            <a:endParaRPr lang="en-US" sz="1050" dirty="0"/>
+          </a:p>
+          <a:p>
+            <a:pPr marL="127000" indent="-127000">
+              <a:spcAft>
+                <a:spcPts val="700"/>
+              </a:spcAft>
+              <a:buSzPct val="100000"/>
+              <a:buChar char="•"/>
+            </a:pPr>
+            <a:r>
+              <a:rPr lang="en-US" sz="1050" dirty="0">
+                <a:solidFill>
+                  <a:srgbClr val="33463C"/>
+                </a:solidFill>
+                <a:latin typeface="Raleway" pitchFamily="34" charset="0"/>
+                <a:ea typeface="Raleway" pitchFamily="34" charset="-122"/>
+                <a:cs typeface="Raleway" pitchFamily="34" charset="-120"/>
+              </a:rPr>
+              <a:t>Offline PWA: home-screen install, wake lock</a:t>
+            </a:r>
+            <a:endParaRPr lang="en-US" sz="1050" dirty="0"/>
+          </a:p>
+          <a:p>
+            <a:pPr marL="127000" indent="-127000">
+              <a:spcAft>
+                <a:spcPts val="700"/>
+              </a:spcAft>
+              <a:buSzPct val="100000"/>
+              <a:buChar char="•"/>
+            </a:pPr>
+            <a:r>
+              <a:rPr lang="en-US" sz="1050" dirty="0">
+                <a:solidFill>
+                  <a:srgbClr val="33463C"/>
+                </a:solidFill>
+                <a:latin typeface="Raleway" pitchFamily="34" charset="0"/>
+                <a:ea typeface="Raleway" pitchFamily="34" charset="-122"/>
+                <a:cs typeface="Raleway" pitchFamily="34" charset="-120"/>
+              </a:rPr>
+              <a:t>No accounts, ads, or data collection</a:t>
+            </a:r>
+            <a:endParaRPr lang="en-US" sz="1050" dirty="0"/>
+          </a:p>
+          <a:p>
+            <a:pPr marL="127000" indent="-127000">
+              <a:spcAft>
+                <a:spcPts val="700"/>
+              </a:spcAft>
+              <a:buSzPct val="100000"/>
+              <a:buChar char="•"/>
+            </a:pPr>
+            <a:r>
+              <a:rPr lang="en-US" sz="1050" dirty="0">
+                <a:solidFill>
+                  <a:srgbClr val="33463C"/>
+                </a:solidFill>
+                <a:latin typeface="Raleway" pitchFamily="34" charset="0"/>
+                <a:ea typeface="Raleway" pitchFamily="34" charset="-122"/>
+                <a:cs typeface="Raleway" pitchFamily="34" charset="-120"/>
+              </a:rPr>
+              <a:t>A little hidden whimsy for those who explore</a:t>
+            </a:r>
+            <a:endParaRPr lang="en-US" sz="1050" dirty="0"/>
+          </a:p>
+        </p:txBody>
+      </p:sp>
+      <p:sp>
+        <p:nvSpPr>
+          <p:cNvPr id="10" name="Text 8"/>
+          <p:cNvSpPr/>
+          <p:nvPr/>
+        </p:nvSpPr>
+        <p:spPr>
+          <a:xfrm>
+            <a:off x="521208" y="6144768"/>
+            <a:ext cx="10058400" cy="274320"/>
+          </a:xfrm>
+          <a:prstGeom prst="rect">
+            <a:avLst/>
+          </a:prstGeom>
+          <a:noFill/>
+          <a:ln/>
+        </p:spPr>
+        <p:txBody>
+          <a:bodyPr wrap="square" lIns="0" tIns="0" rIns="0" bIns="0" rtlCol="0" anchor="ctr"/>
+          <a:lstStyle/>
+          <a:p>
+            <a:pPr indent="0" marL="0">
+              <a:buNone/>
+            </a:pPr>
+            <a:r>
+              <a:rPr lang="en-US" sz="1000" i="1" dirty="0">
+                <a:solidFill>
+                  <a:srgbClr val="5F7468"/>
+                </a:solidFill>
+                <a:latin typeface="Raleway" pitchFamily="34" charset="0"/>
+                <a:ea typeface="Raleway" pitchFamily="34" charset="-122"/>
+                <a:cs typeface="Raleway" pitchFamily="34" charset="-120"/>
+              </a:rPr>
+              <a:t>Full walkthrough: wbyc-user-guide.md ships with the app.</a:t>
+            </a:r>
+            <a:endParaRPr lang="en-US" sz="1000" dirty="0"/>
+          </a:p>
+        </p:txBody>
+      </p:sp>
+      <p:sp>
+        <p:nvSpPr>
+          <p:cNvPr id="11" name="Text 9"/>
+          <p:cNvSpPr/>
+          <p:nvPr/>
+        </p:nvSpPr>
+        <p:spPr>
+          <a:xfrm>
+            <a:off x="502920" y="6473952"/>
+            <a:ext cx="5486400" cy="274320"/>
+          </a:xfrm>
+          <a:prstGeom prst="rect">
+            <a:avLst/>
+          </a:prstGeom>
+          <a:noFill/>
+          <a:ln/>
+        </p:spPr>
+        <p:txBody>
+          <a:bodyPr wrap="square" lIns="0" tIns="0" rIns="0" bIns="0" rtlCol="0" anchor="ctr"/>
+          <a:lstStyle/>
+          <a:p>
+            <a:pPr indent="0" marL="0">
+              <a:buNone/>
+            </a:pPr>
+            <a:r>
+              <a:rPr lang="en-US" sz="900" dirty="0">
+                <a:solidFill>
+                  <a:srgbClr val="5F7468"/>
+                </a:solidFill>
+                <a:latin typeface="Raleway" pitchFamily="34" charset="0"/>
+                <a:ea typeface="Raleway" pitchFamily="34" charset="-122"/>
+                <a:cs typeface="Raleway" pitchFamily="34" charset="-120"/>
+              </a:rPr>
+              <a:t>WBYC Rangefinder · a member-built proposal · 13</a:t>
+            </a:r>
+            <a:endParaRPr lang="en-US" sz="900" dirty="0"/>
+          </a:p>
+        </p:txBody>
+      </p:sp>
+    </p:spTree>
+  </p:cSld>
+  <p:clrMapOvr>
+    <a:masterClrMapping/>
+  </p:clrMapOvr>
+</p:sld>
+</file>
+
+<file path=ppt/slides/slide14.xml><?xml version="1.0" encoding="utf-8"?>
+<p:sld xmlns:a="http://schemas.openxmlformats.org/drawingml/2006/main" xmlns:r="http://schemas.openxmlformats.org/officeDocument/2006/relationships" xmlns:p="http://schemas.openxmlformats.org/presentationml/2006/main">
+  <p:cSld name="Slide 14">
     <p:bg>
       <p:bgPr>
         <a:blipFill dpi="0" rotWithShape="1">

</xml_diff>

<commit_message>
Pin sheet added to guide feature list + deck (slide 2, inventory, roadmap NOW incl. Green tees)
</commit_message>
<xml_diff>
--- a/WBYC-Rangefinder-Pitch.pptx
+++ b/WBYC-Rangefinder-Pitch.pptx
@@ -3512,7 +3512,7 @@
                 <a:ea typeface="Raleway" pitchFamily="34" charset="-122"/>
                 <a:cs typeface="Raleway" pitchFamily="34" charset="-120"/>
               </a:rPr>
-              <a:t>Shot tracer with flight stats, plays-like profile view, green fall-lines, club-distance learning, scorecard + GHIN helper, offline install</a:t>
+              <a:t>Shot tracer with flight stats, pin-sheet mode, plays-like profile view, green fall-lines, club-distance learning, all five tee sets incl. the new Greens, scorecard + GHIN helper, offline install</a:t>
             </a:r>
             <a:endParaRPr lang="en-US" sz="1350" dirty="0"/>
           </a:p>
@@ -4655,6 +4655,27 @@
                 <a:cs typeface="Raleway" pitchFamily="34" charset="-120"/>
               </a:rPr>
               <a:t>Ball-flight tracer: map arc, side profile, 3D flyover + stats</a:t>
+            </a:r>
+            <a:endParaRPr lang="en-US" sz="1050" dirty="0"/>
+          </a:p>
+          <a:p>
+            <a:pPr marL="127000" indent="-127000">
+              <a:spcAft>
+                <a:spcPts val="700"/>
+              </a:spcAft>
+              <a:buSzPct val="100000"/>
+              <a:buChar char="•"/>
+            </a:pPr>
+            <a:r>
+              <a:rPr lang="en-US" sz="1050" dirty="0">
+                <a:solidFill>
+                  <a:srgbClr val="33463C"/>
+                </a:solidFill>
+                <a:latin typeface="Raleway" pitchFamily="34" charset="0"/>
+                <a:ea typeface="Raleway" pitchFamily="34" charset="-122"/>
+                <a:cs typeface="Raleway" pitchFamily="34" charset="-120"/>
+              </a:rPr>
+              <a:t>Pin sheet: tap today’s pin — every number re-keys to it</a:t>
             </a:r>
             <a:endParaRPr lang="en-US" sz="1050" dirty="0"/>
           </a:p>
@@ -5611,7 +5632,7 @@
                 <a:ea typeface="Raleway" pitchFamily="34" charset="-122"/>
                 <a:cs typeface="Raleway" pitchFamily="34" charset="-120"/>
               </a:rPr>
-              <a:t>Front / center / back to every green, live hazard carries, dogleg targets — tuned to our 18 and nothing else.</a:t>
+              <a:t>Front / center / back to every green — or tap in today’s actual pin and every number re-keys to it. Live hazard carries, dogleg targets.</a:t>
             </a:r>
             <a:endParaRPr lang="en-US" sz="1250" dirty="0"/>
           </a:p>

</xml_diff>

<commit_message>
Deck: deal-structures appendix (annual/declining/capped/buyout + F&B currency) + perpetuity objection ladder in proposal speaker notes
</commit_message>
<xml_diff>
--- a/WBYC-Rangefinder-Pitch.pptx
+++ b/WBYC-Rangefinder-Pitch.pptx
@@ -19,9 +19,10 @@
     <p:sldId id="267" r:id="rId13"/>
     <p:sldId id="268" r:id="rId14"/>
     <p:sldId id="269" r:id="rId15"/>
+    <p:sldId id="270" r:id="rId16"/>
   </p:sldIdLst>
   <p:notesMasterIdLst>
-    <p:notesMasterId r:id="rId16"/>
+    <p:notesMasterId r:id="rId17"/>
   </p:notesMasterIdLst>
   <p:sldSz cx="12192000" cy="6858000"/>
   <p:notesSz cx="6858000" cy="12192000"/>
@@ -955,7 +956,7 @@
           <a:p>
             <a:r>
               <a:rPr lang="en-US" dirty="0"/>
-              <a:t>Close by offering a live demo round with the membership committee.</a:t>
+              <a:t>Lead with the top-left card — it is the actual proposal. The other three are concessions; offer them in reading order and stop as soon as one lands.</a:t>
             </a:r>
             <a:endParaRPr lang="en-US" dirty="0"/>
           </a:p>
@@ -979,6 +980,94 @@
             <a:fld id="{F7021451-1387-4CA6-816F-3879F97B5CBC}" type="slidenum">
               <a:rPr lang="en-US"/>
               <a:t>14</a:t>
+            </a:fld>
+            <a:endParaRPr lang="en-US"/>
+          </a:p>
+        </p:txBody>
+      </p:sp>
+    </p:spTree>
+    <p:extLst>
+      <p:ext uri="{BB962C8B-B14F-4D97-AF65-F5344CB8AC3E}">
+        <p14:creationId xmlns:p14="http://schemas.microsoft.com/office/powerpoint/2010/main" val="1024086991"/>
+      </p:ext>
+    </p:extLst>
+  </p:cSld>
+  <p:clrMapOvr>
+    <a:masterClrMapping/>
+  </p:clrMapOvr>
+</p:notes>
+</file>
+
+<file path=ppt/notesSlides/notesSlide15.xml><?xml version="1.0" encoding="utf-8"?>
+<p:notes xmlns:a="http://schemas.openxmlformats.org/drawingml/2006/main" xmlns:r="http://schemas.openxmlformats.org/officeDocument/2006/relationships" xmlns:p="http://schemas.openxmlformats.org/presentationml/2006/main">
+  <p:cSld>
+    <p:spTree>
+      <p:nvGrpSpPr>
+        <p:cNvPr id="1" name=""/>
+        <p:cNvGrpSpPr/>
+        <p:nvPr/>
+      </p:nvGrpSpPr>
+      <p:grpSpPr>
+        <a:xfrm>
+          <a:off x="0" y="0"/>
+          <a:ext cx="0" cy="0"/>
+          <a:chOff x="0" y="0"/>
+          <a:chExt cx="0" cy="0"/>
+        </a:xfrm>
+      </p:grpSpPr>
+      <p:sp>
+        <p:nvSpPr>
+          <p:cNvPr id="2" name="Slide Image Placeholder 1"/>
+          <p:cNvSpPr>
+            <a:spLocks noGrp="1" noRot="1" noChangeAspect="1"/>
+          </p:cNvSpPr>
+          <p:nvPr>
+            <p:ph type="sldImg"/>
+          </p:nvPr>
+        </p:nvSpPr>
+        <p:spPr/>
+      </p:sp>
+      <p:sp>
+        <p:nvSpPr>
+          <p:cNvPr id="3" name="Notes Placeholder 2"/>
+          <p:cNvSpPr>
+            <a:spLocks noGrp="1"/>
+          </p:cNvSpPr>
+          <p:nvPr>
+            <p:ph type="body" idx="1"/>
+          </p:nvPr>
+        </p:nvSpPr>
+        <p:spPr/>
+        <p:txBody>
+          <a:bodyPr/>
+          <a:lstStyle/>
+          <a:p>
+            <a:r>
+              <a:rPr lang="en-US" dirty="0"/>
+              <a:t>Close by offering a live demo round with the membership committee.</a:t>
+            </a:r>
+            <a:endParaRPr lang="en-US" dirty="0"/>
+          </a:p>
+        </p:txBody>
+      </p:sp>
+      <p:sp>
+        <p:nvSpPr>
+          <p:cNvPr id="4" name="Slide Number Placeholder 3"/>
+          <p:cNvSpPr>
+            <a:spLocks noGrp="1"/>
+          </p:cNvSpPr>
+          <p:nvPr>
+            <p:ph type="sldNum" sz="quarter" idx="10"/>
+          </p:nvPr>
+        </p:nvSpPr>
+        <p:spPr/>
+        <p:txBody>
+          <a:bodyPr/>
+          <a:lstStyle/>
+          <a:p>
+            <a:fld id="{F7021451-1387-4CA6-816F-3879F97B5CBC}" type="slidenum">
+              <a:rPr lang="en-US"/>
+              <a:t>15</a:t>
             </a:fld>
             <a:endParaRPr lang="en-US"/>
           </a:p>
@@ -1659,7 +1748,8 @@
           <a:p>
             <a:r>
               <a:rPr lang="en-US" dirty="0"/>
-              <a:t>If asked "why not one-time?": a one-time sale hands the club a depreciating asset; the annual trade buys a living service — seasonal re-survey, fixes, roadmap — and the ask sits below the $18K/yr member-value ceiling. Either side can walk at renewal.</a:t>
+              <a:t>If asked "why not one-time?": a one-time sale hands the club a depreciating asset; the annual trade buys a living service — seasonal re-survey, fixes, roadmap — and the ask sits below the $18K/yr member-value ceiling. Either side can walk at renewal.
+If they balk at "discounting dues in perpetuity": (1) Reframe — it is not perpetual, it is an annual subscription the club can cancel; renewal is earned each spring by visible work (the app matched the new 4/2026 scorecard the same season). (2) Mirror — the club already pays software forever: the website runs on Jonas Club Software, invoiced annually. Same line item, zero cash, member vendor. (3) Fallback ladder, concede in this order: declining schedule (full credit yrs 1-2, half after) → capped trade (credits stop at an agreed build value, ~$45-75K anchor, then paid-up license + small retainer) → buyout option (convert to perpetual license anytime, price minus dues already traded). (4) If dues are sacred, switch currency: F&amp;B credit or guest passes pass easier than touching the dues ledger.</a:t>
             </a:r>
             <a:endParaRPr lang="en-US" dirty="0"/>
           </a:p>
@@ -5249,6 +5339,614 @@
 <file path=ppt/slides/slide14.xml><?xml version="1.0" encoding="utf-8"?>
 <p:sld xmlns:a="http://schemas.openxmlformats.org/drawingml/2006/main" xmlns:r="http://schemas.openxmlformats.org/officeDocument/2006/relationships" xmlns:p="http://schemas.openxmlformats.org/presentationml/2006/main">
   <p:cSld name="Slide 14">
+    <p:bg>
+      <p:bgPr>
+        <a:solidFill>
+          <a:srgbClr val="F4FBF6"/>
+        </a:solidFill>
+      </p:bgPr>
+    </p:bg>
+    <p:spTree>
+      <p:nvGrpSpPr>
+        <p:cNvPr id="1" name=""/>
+        <p:cNvGrpSpPr/>
+        <p:nvPr/>
+      </p:nvGrpSpPr>
+      <p:grpSpPr>
+        <a:xfrm>
+          <a:off x="0" y="0"/>
+          <a:ext cx="0" cy="0"/>
+          <a:chOff x="0" y="0"/>
+          <a:chExt cx="0" cy="0"/>
+        </a:xfrm>
+      </p:grpSpPr>
+      <p:sp>
+        <p:nvSpPr>
+          <p:cNvPr id="2" name="Text 0"/>
+          <p:cNvSpPr/>
+          <p:nvPr/>
+        </p:nvSpPr>
+        <p:spPr>
+          <a:xfrm>
+            <a:off x="502920" y="384048"/>
+            <a:ext cx="10515600" cy="685800"/>
+          </a:xfrm>
+          <a:prstGeom prst="rect">
+            <a:avLst/>
+          </a:prstGeom>
+          <a:noFill/>
+          <a:ln/>
+        </p:spPr>
+        <p:txBody>
+          <a:bodyPr wrap="square" lIns="0" tIns="0" rIns="0" bIns="0" rtlCol="0" anchor="ctr"/>
+          <a:lstStyle/>
+          <a:p>
+            <a:pPr indent="0" marL="0">
+              <a:buNone/>
+            </a:pPr>
+            <a:r>
+              <a:rPr lang="en-US" sz="3600" b="1" dirty="0">
+                <a:solidFill>
+                  <a:srgbClr val="0E2A1C"/>
+                </a:solidFill>
+                <a:latin typeface="Didot" pitchFamily="34" charset="0"/>
+                <a:ea typeface="Didot" pitchFamily="34" charset="-122"/>
+                <a:cs typeface="Didot" pitchFamily="34" charset="-120"/>
+              </a:rPr>
+              <a:t>Appendix: four ways to structure it</a:t>
+            </a:r>
+            <a:endParaRPr lang="en-US" sz="3600" dirty="0"/>
+          </a:p>
+        </p:txBody>
+      </p:sp>
+      <p:sp>
+        <p:nvSpPr>
+          <p:cNvPr id="3" name="Text 1"/>
+          <p:cNvSpPr/>
+          <p:nvPr/>
+        </p:nvSpPr>
+        <p:spPr>
+          <a:xfrm>
+            <a:off x="521208" y="1078992"/>
+            <a:ext cx="10972800" cy="566928"/>
+          </a:xfrm>
+          <a:prstGeom prst="rect">
+            <a:avLst/>
+          </a:prstGeom>
+          <a:noFill/>
+          <a:ln/>
+        </p:spPr>
+        <p:txBody>
+          <a:bodyPr wrap="square" lIns="0" tIns="0" rIns="0" bIns="0" rtlCol="0" anchor="ctr"/>
+          <a:lstStyle/>
+          <a:p>
+            <a:pPr indent="0" marL="0">
+              <a:buNone/>
+            </a:pPr>
+            <a:r>
+              <a:rPr lang="en-US" sz="1350" i="1" dirty="0">
+                <a:solidFill>
+                  <a:srgbClr val="5F7468"/>
+                </a:solidFill>
+                <a:latin typeface="Raleway" pitchFamily="34" charset="0"/>
+                <a:ea typeface="Raleway" pitchFamily="34" charset="-122"/>
+                <a:cs typeface="Raleway" pitchFamily="34" charset="-120"/>
+              </a:rPr>
+              <a:t>Nothing here is "in perpetuity" — every structure has a built-in exit. The club already licenses software annually (its own website runs on Jonas Club Software); this is the same line item, paid in trade.</a:t>
+            </a:r>
+            <a:endParaRPr lang="en-US" sz="1350" dirty="0"/>
+          </a:p>
+        </p:txBody>
+      </p:sp>
+      <p:sp>
+        <p:nvSpPr>
+          <p:cNvPr id="4" name="Shape 2"/>
+          <p:cNvSpPr/>
+          <p:nvPr/>
+        </p:nvSpPr>
+        <p:spPr>
+          <a:xfrm>
+            <a:off x="502920" y="1874520"/>
+            <a:ext cx="5376672" cy="1783080"/>
+          </a:xfrm>
+          <a:prstGeom prst="roundRect">
+            <a:avLst>
+              <a:gd name="adj" fmla="val 7179"/>
+            </a:avLst>
+          </a:prstGeom>
+          <a:solidFill>
+            <a:srgbClr val="0E2A1C"/>
+          </a:solidFill>
+          <a:ln w="12700">
+            <a:solidFill>
+              <a:srgbClr val="D5E8DC"/>
+            </a:solidFill>
+            <a:prstDash val="solid"/>
+          </a:ln>
+        </p:spPr>
+      </p:sp>
+      <p:sp>
+        <p:nvSpPr>
+          <p:cNvPr id="5" name="Text 3"/>
+          <p:cNvSpPr/>
+          <p:nvPr/>
+        </p:nvSpPr>
+        <p:spPr>
+          <a:xfrm>
+            <a:off x="777240" y="2057400"/>
+            <a:ext cx="4846320" cy="365760"/>
+          </a:xfrm>
+          <a:prstGeom prst="rect">
+            <a:avLst/>
+          </a:prstGeom>
+          <a:noFill/>
+          <a:ln/>
+        </p:spPr>
+        <p:txBody>
+          <a:bodyPr wrap="square" lIns="0" tIns="0" rIns="0" bIns="0" rtlCol="0" anchor="ctr"/>
+          <a:lstStyle/>
+          <a:p>
+            <a:pPr indent="0" marL="0">
+              <a:buNone/>
+            </a:pPr>
+            <a:r>
+              <a:rPr lang="en-US" sz="1450" b="1" dirty="0">
+                <a:solidFill>
+                  <a:srgbClr val="FFA5EB"/>
+                </a:solidFill>
+                <a:latin typeface="Raleway" pitchFamily="34" charset="0"/>
+                <a:ea typeface="Raleway" pitchFamily="34" charset="-122"/>
+                <a:cs typeface="Raleway" pitchFamily="34" charset="-120"/>
+              </a:rPr>
+              <a:t>Annual renewal  ·  as proposed</a:t>
+            </a:r>
+            <a:endParaRPr lang="en-US" sz="1450" dirty="0"/>
+          </a:p>
+        </p:txBody>
+      </p:sp>
+      <p:sp>
+        <p:nvSpPr>
+          <p:cNvPr id="6" name="Text 4"/>
+          <p:cNvSpPr/>
+          <p:nvPr/>
+        </p:nvSpPr>
+        <p:spPr>
+          <a:xfrm>
+            <a:off x="777240" y="2468880"/>
+            <a:ext cx="4846320" cy="1051560"/>
+          </a:xfrm>
+          <a:prstGeom prst="rect">
+            <a:avLst/>
+          </a:prstGeom>
+          <a:noFill/>
+          <a:ln/>
+        </p:spPr>
+        <p:txBody>
+          <a:bodyPr wrap="square" lIns="0" tIns="0" rIns="0" bIns="0" rtlCol="0" anchor="ctr"/>
+          <a:lstStyle/>
+          <a:p>
+            <a:pPr indent="0" marL="0">
+              <a:buNone/>
+            </a:pPr>
+            <a:r>
+              <a:rPr lang="en-US" sz="1150" dirty="0">
+                <a:solidFill>
+                  <a:srgbClr val="C9EED9"/>
+                </a:solidFill>
+                <a:latin typeface="Raleway" pitchFamily="34" charset="0"/>
+                <a:ea typeface="Raleway" pitchFamily="34" charset="-122"/>
+                <a:cs typeface="Raleway" pitchFamily="34" charset="-120"/>
+              </a:rPr>
+              <a:t>Dues credited year to year; either side can walk each spring. Renewal is earned by visible work — data refresh, fixes, new features.</a:t>
+            </a:r>
+            <a:endParaRPr lang="en-US" sz="1150" dirty="0"/>
+          </a:p>
+        </p:txBody>
+      </p:sp>
+      <p:sp>
+        <p:nvSpPr>
+          <p:cNvPr id="7" name="Shape 5"/>
+          <p:cNvSpPr/>
+          <p:nvPr/>
+        </p:nvSpPr>
+        <p:spPr>
+          <a:xfrm>
+            <a:off x="6309360" y="1874520"/>
+            <a:ext cx="5376672" cy="1783080"/>
+          </a:xfrm>
+          <a:prstGeom prst="roundRect">
+            <a:avLst>
+              <a:gd name="adj" fmla="val 7179"/>
+            </a:avLst>
+          </a:prstGeom>
+          <a:solidFill>
+            <a:srgbClr val="FFFFFF"/>
+          </a:solidFill>
+          <a:ln w="12700">
+            <a:solidFill>
+              <a:srgbClr val="D5E8DC"/>
+            </a:solidFill>
+            <a:prstDash val="solid"/>
+          </a:ln>
+        </p:spPr>
+      </p:sp>
+      <p:sp>
+        <p:nvSpPr>
+          <p:cNvPr id="8" name="Text 6"/>
+          <p:cNvSpPr/>
+          <p:nvPr/>
+        </p:nvSpPr>
+        <p:spPr>
+          <a:xfrm>
+            <a:off x="6583680" y="2057400"/>
+            <a:ext cx="4846320" cy="365760"/>
+          </a:xfrm>
+          <a:prstGeom prst="rect">
+            <a:avLst/>
+          </a:prstGeom>
+          <a:noFill/>
+          <a:ln/>
+        </p:spPr>
+        <p:txBody>
+          <a:bodyPr wrap="square" lIns="0" tIns="0" rIns="0" bIns="0" rtlCol="0" anchor="ctr"/>
+          <a:lstStyle/>
+          <a:p>
+            <a:pPr indent="0" marL="0">
+              <a:buNone/>
+            </a:pPr>
+            <a:r>
+              <a:rPr lang="en-US" sz="1450" b="1" dirty="0">
+                <a:solidFill>
+                  <a:srgbClr val="1E7A4A"/>
+                </a:solidFill>
+                <a:latin typeface="Raleway" pitchFamily="34" charset="0"/>
+                <a:ea typeface="Raleway" pitchFamily="34" charset="-122"/>
+                <a:cs typeface="Raleway" pitchFamily="34" charset="-120"/>
+              </a:rPr>
+              <a:t>Declining schedule</a:t>
+            </a:r>
+            <a:endParaRPr lang="en-US" sz="1450" dirty="0"/>
+          </a:p>
+        </p:txBody>
+      </p:sp>
+      <p:sp>
+        <p:nvSpPr>
+          <p:cNvPr id="9" name="Text 7"/>
+          <p:cNvSpPr/>
+          <p:nvPr/>
+        </p:nvSpPr>
+        <p:spPr>
+          <a:xfrm>
+            <a:off x="6583680" y="2468880"/>
+            <a:ext cx="4846320" cy="1051560"/>
+          </a:xfrm>
+          <a:prstGeom prst="rect">
+            <a:avLst/>
+          </a:prstGeom>
+          <a:noFill/>
+          <a:ln/>
+        </p:spPr>
+        <p:txBody>
+          <a:bodyPr wrap="square" lIns="0" tIns="0" rIns="0" bIns="0" rtlCol="0" anchor="ctr"/>
+          <a:lstStyle/>
+          <a:p>
+            <a:pPr indent="0" marL="0">
+              <a:buNone/>
+            </a:pPr>
+            <a:r>
+              <a:rPr lang="en-US" sz="1150" dirty="0">
+                <a:solidFill>
+                  <a:srgbClr val="33463C"/>
+                </a:solidFill>
+                <a:latin typeface="Raleway" pitchFamily="34" charset="0"/>
+                <a:ea typeface="Raleway" pitchFamily="34" charset="-122"/>
+                <a:cs typeface="Raleway" pitchFamily="34" charset="-120"/>
+              </a:rPr>
+              <a:t>Full dues credit in years 1–2 (recovering the build), stepping to half thereafter as pure maintenance.</a:t>
+            </a:r>
+            <a:endParaRPr lang="en-US" sz="1150" dirty="0"/>
+          </a:p>
+        </p:txBody>
+      </p:sp>
+      <p:sp>
+        <p:nvSpPr>
+          <p:cNvPr id="10" name="Shape 8"/>
+          <p:cNvSpPr/>
+          <p:nvPr/>
+        </p:nvSpPr>
+        <p:spPr>
+          <a:xfrm>
+            <a:off x="502920" y="3886200"/>
+            <a:ext cx="5376672" cy="1783080"/>
+          </a:xfrm>
+          <a:prstGeom prst="roundRect">
+            <a:avLst>
+              <a:gd name="adj" fmla="val 7179"/>
+            </a:avLst>
+          </a:prstGeom>
+          <a:solidFill>
+            <a:srgbClr val="FFFFFF"/>
+          </a:solidFill>
+          <a:ln w="12700">
+            <a:solidFill>
+              <a:srgbClr val="D5E8DC"/>
+            </a:solidFill>
+            <a:prstDash val="solid"/>
+          </a:ln>
+        </p:spPr>
+      </p:sp>
+      <p:sp>
+        <p:nvSpPr>
+          <p:cNvPr id="11" name="Text 9"/>
+          <p:cNvSpPr/>
+          <p:nvPr/>
+        </p:nvSpPr>
+        <p:spPr>
+          <a:xfrm>
+            <a:off x="777240" y="4069080"/>
+            <a:ext cx="4846320" cy="365760"/>
+          </a:xfrm>
+          <a:prstGeom prst="rect">
+            <a:avLst/>
+          </a:prstGeom>
+          <a:noFill/>
+          <a:ln/>
+        </p:spPr>
+        <p:txBody>
+          <a:bodyPr wrap="square" lIns="0" tIns="0" rIns="0" bIns="0" rtlCol="0" anchor="ctr"/>
+          <a:lstStyle/>
+          <a:p>
+            <a:pPr indent="0" marL="0">
+              <a:buNone/>
+            </a:pPr>
+            <a:r>
+              <a:rPr lang="en-US" sz="1450" b="1" dirty="0">
+                <a:solidFill>
+                  <a:srgbClr val="1E7A4A"/>
+                </a:solidFill>
+                <a:latin typeface="Raleway" pitchFamily="34" charset="0"/>
+                <a:ea typeface="Raleway" pitchFamily="34" charset="-122"/>
+                <a:cs typeface="Raleway" pitchFamily="34" charset="-120"/>
+              </a:rPr>
+              <a:t>Capped trade</a:t>
+            </a:r>
+            <a:endParaRPr lang="en-US" sz="1450" dirty="0"/>
+          </a:p>
+        </p:txBody>
+      </p:sp>
+      <p:sp>
+        <p:nvSpPr>
+          <p:cNvPr id="12" name="Text 10"/>
+          <p:cNvSpPr/>
+          <p:nvPr/>
+        </p:nvSpPr>
+        <p:spPr>
+          <a:xfrm>
+            <a:off x="777240" y="4480560"/>
+            <a:ext cx="4846320" cy="1051560"/>
+          </a:xfrm>
+          <a:prstGeom prst="rect">
+            <a:avLst/>
+          </a:prstGeom>
+          <a:noFill/>
+          <a:ln/>
+        </p:spPr>
+        <p:txBody>
+          <a:bodyPr wrap="square" lIns="0" tIns="0" rIns="0" bIns="0" rtlCol="0" anchor="ctr"/>
+          <a:lstStyle/>
+          <a:p>
+            <a:pPr indent="0" marL="0">
+              <a:buNone/>
+            </a:pPr>
+            <a:r>
+              <a:rPr lang="en-US" sz="1150" dirty="0">
+                <a:solidFill>
+                  <a:srgbClr val="33463C"/>
+                </a:solidFill>
+                <a:latin typeface="Raleway" pitchFamily="34" charset="0"/>
+                <a:ea typeface="Raleway" pitchFamily="34" charset="-122"/>
+                <a:cs typeface="Raleway" pitchFamily="34" charset="-120"/>
+              </a:rPr>
+              <a:t>Credits accumulate to an agreed build value ($45K–$75K lens); the club then holds a paid-up license with a small annual retainer.</a:t>
+            </a:r>
+            <a:endParaRPr lang="en-US" sz="1150" dirty="0"/>
+          </a:p>
+        </p:txBody>
+      </p:sp>
+      <p:sp>
+        <p:nvSpPr>
+          <p:cNvPr id="13" name="Shape 11"/>
+          <p:cNvSpPr/>
+          <p:nvPr/>
+        </p:nvSpPr>
+        <p:spPr>
+          <a:xfrm>
+            <a:off x="6309360" y="3886200"/>
+            <a:ext cx="5376672" cy="1783080"/>
+          </a:xfrm>
+          <a:prstGeom prst="roundRect">
+            <a:avLst>
+              <a:gd name="adj" fmla="val 7179"/>
+            </a:avLst>
+          </a:prstGeom>
+          <a:solidFill>
+            <a:srgbClr val="FFFFFF"/>
+          </a:solidFill>
+          <a:ln w="12700">
+            <a:solidFill>
+              <a:srgbClr val="D5E8DC"/>
+            </a:solidFill>
+            <a:prstDash val="solid"/>
+          </a:ln>
+        </p:spPr>
+      </p:sp>
+      <p:sp>
+        <p:nvSpPr>
+          <p:cNvPr id="14" name="Text 12"/>
+          <p:cNvSpPr/>
+          <p:nvPr/>
+        </p:nvSpPr>
+        <p:spPr>
+          <a:xfrm>
+            <a:off x="6583680" y="4069080"/>
+            <a:ext cx="4846320" cy="365760"/>
+          </a:xfrm>
+          <a:prstGeom prst="rect">
+            <a:avLst/>
+          </a:prstGeom>
+          <a:noFill/>
+          <a:ln/>
+        </p:spPr>
+        <p:txBody>
+          <a:bodyPr wrap="square" lIns="0" tIns="0" rIns="0" bIns="0" rtlCol="0" anchor="ctr"/>
+          <a:lstStyle/>
+          <a:p>
+            <a:pPr indent="0" marL="0">
+              <a:buNone/>
+            </a:pPr>
+            <a:r>
+              <a:rPr lang="en-US" sz="1450" b="1" dirty="0">
+                <a:solidFill>
+                  <a:srgbClr val="1E7A4A"/>
+                </a:solidFill>
+                <a:latin typeface="Raleway" pitchFamily="34" charset="0"/>
+                <a:ea typeface="Raleway" pitchFamily="34" charset="-122"/>
+                <a:cs typeface="Raleway" pitchFamily="34" charset="-120"/>
+              </a:rPr>
+              <a:t>Buyout option</a:t>
+            </a:r>
+            <a:endParaRPr lang="en-US" sz="1450" dirty="0"/>
+          </a:p>
+        </p:txBody>
+      </p:sp>
+      <p:sp>
+        <p:nvSpPr>
+          <p:cNvPr id="15" name="Text 13"/>
+          <p:cNvSpPr/>
+          <p:nvPr/>
+        </p:nvSpPr>
+        <p:spPr>
+          <a:xfrm>
+            <a:off x="6583680" y="4480560"/>
+            <a:ext cx="4846320" cy="1051560"/>
+          </a:xfrm>
+          <a:prstGeom prst="rect">
+            <a:avLst/>
+          </a:prstGeom>
+          <a:noFill/>
+          <a:ln/>
+        </p:spPr>
+        <p:txBody>
+          <a:bodyPr wrap="square" lIns="0" tIns="0" rIns="0" bIns="0" rtlCol="0" anchor="ctr"/>
+          <a:lstStyle/>
+          <a:p>
+            <a:pPr indent="0" marL="0">
+              <a:buNone/>
+            </a:pPr>
+            <a:r>
+              <a:rPr lang="en-US" sz="1150" dirty="0">
+                <a:solidFill>
+                  <a:srgbClr val="33463C"/>
+                </a:solidFill>
+                <a:latin typeface="Raleway" pitchFamily="34" charset="0"/>
+                <a:ea typeface="Raleway" pitchFamily="34" charset="-122"/>
+                <a:cs typeface="Raleway" pitchFamily="34" charset="-120"/>
+              </a:rPr>
+              <a:t>Convert to a perpetual license anytime for a fixed sum minus dues already traded — an exit that never gets more expensive.</a:t>
+            </a:r>
+            <a:endParaRPr lang="en-US" sz="1150" dirty="0"/>
+          </a:p>
+        </p:txBody>
+      </p:sp>
+      <p:sp>
+        <p:nvSpPr>
+          <p:cNvPr id="16" name="Text 14"/>
+          <p:cNvSpPr/>
+          <p:nvPr/>
+        </p:nvSpPr>
+        <p:spPr>
+          <a:xfrm>
+            <a:off x="521208" y="5989320"/>
+            <a:ext cx="10515600" cy="320040"/>
+          </a:xfrm>
+          <a:prstGeom prst="rect">
+            <a:avLst/>
+          </a:prstGeom>
+          <a:noFill/>
+          <a:ln/>
+        </p:spPr>
+        <p:txBody>
+          <a:bodyPr wrap="square" lIns="0" tIns="0" rIns="0" bIns="0" rtlCol="0" anchor="ctr"/>
+          <a:lstStyle/>
+          <a:p>
+            <a:pPr indent="0" marL="0">
+              <a:buNone/>
+            </a:pPr>
+            <a:r>
+              <a:rPr lang="en-US" sz="1100" i="1" dirty="0">
+                <a:solidFill>
+                  <a:srgbClr val="5F7468"/>
+                </a:solidFill>
+                <a:latin typeface="Raleway" pitchFamily="34" charset="0"/>
+                <a:ea typeface="Raleway" pitchFamily="34" charset="-122"/>
+                <a:cs typeface="Raleway" pitchFamily="34" charset="-120"/>
+              </a:rPr>
+              <a:t>If dues are the sticking point, the same value trades cleanly as F&amp;B credit or guest passes.</a:t>
+            </a:r>
+            <a:endParaRPr lang="en-US" sz="1100" dirty="0"/>
+          </a:p>
+        </p:txBody>
+      </p:sp>
+      <p:sp>
+        <p:nvSpPr>
+          <p:cNvPr id="18" name="Text 15"/>
+          <p:cNvSpPr/>
+          <p:nvPr/>
+        </p:nvSpPr>
+        <p:spPr>
+          <a:xfrm>
+            <a:off x="502920" y="6473952"/>
+            <a:ext cx="5486400" cy="274320"/>
+          </a:xfrm>
+          <a:prstGeom prst="rect">
+            <a:avLst/>
+          </a:prstGeom>
+          <a:noFill/>
+          <a:ln/>
+        </p:spPr>
+        <p:txBody>
+          <a:bodyPr wrap="square" lIns="0" tIns="0" rIns="0" bIns="0" rtlCol="0" anchor="ctr"/>
+          <a:lstStyle/>
+          <a:p>
+            <a:pPr indent="0" marL="0">
+              <a:buNone/>
+            </a:pPr>
+            <a:r>
+              <a:rPr lang="en-US" sz="900" dirty="0">
+                <a:solidFill>
+                  <a:srgbClr val="5F7468"/>
+                </a:solidFill>
+                <a:latin typeface="Raleway" pitchFamily="34" charset="0"/>
+                <a:ea typeface="Raleway" pitchFamily="34" charset="-122"/>
+                <a:cs typeface="Raleway" pitchFamily="34" charset="-120"/>
+              </a:rPr>
+              <a:t>WBYC Rangefinder · a member-built proposal · 14</a:t>
+            </a:r>
+            <a:endParaRPr lang="en-US" sz="900" dirty="0"/>
+          </a:p>
+        </p:txBody>
+      </p:sp>
+    </p:spTree>
+  </p:cSld>
+  <p:clrMapOvr>
+    <a:masterClrMapping/>
+  </p:clrMapOvr>
+</p:sld>
+</file>
+
+<file path=ppt/slides/slide15.xml><?xml version="1.0" encoding="utf-8"?>
+<p:sld xmlns:a="http://schemas.openxmlformats.org/drawingml/2006/main" xmlns:r="http://schemas.openxmlformats.org/officeDocument/2006/relationships" xmlns:p="http://schemas.openxmlformats.org/presentationml/2006/main">
+  <p:cSld name="Slide 15">
     <p:bg>
       <p:bgPr>
         <a:blipFill dpi="0" rotWithShape="1">

</xml_diff>

<commit_message>
Proposal slide: Jonas-integration bullet (menu link in the WBYC app, no vendor coordination)
</commit_message>
<xml_diff>
--- a/WBYC-Rangefinder-Pitch.pptx
+++ b/WBYC-Rangefinder-Pitch.pptx
@@ -11584,6 +11584,27 @@
                 <a:ea typeface="Raleway" pitchFamily="34" charset="-122"/>
                 <a:cs typeface="Raleway" pitchFamily="34" charset="-120"/>
               </a:rPr>
+              <a:t>Can be integrated into the WBYC app: works alongside the club’s existing Jonas system as a simple menu link — no vendor coordination required</a:t>
+            </a:r>
+            <a:endParaRPr lang="en-US" sz="1450" dirty="0"/>
+          </a:p>
+          <a:p>
+            <a:pPr marL="342900" indent="-342900">
+              <a:spcAft>
+                <a:spcPts val="1000"/>
+              </a:spcAft>
+              <a:buSzPct val="100000"/>
+              <a:buChar char="•"/>
+            </a:pPr>
+            <a:r>
+              <a:rPr lang="en-US" sz="1450" dirty="0">
+                <a:solidFill>
+                  <a:srgbClr val="22352B"/>
+                </a:solidFill>
+                <a:latin typeface="Raleway" pitchFamily="34" charset="0"/>
+                <a:ea typeface="Raleway" pitchFamily="34" charset="-122"/>
+                <a:cs typeface="Raleway" pitchFamily="34" charset="-120"/>
+              </a:rPr>
               <a:t>Reasonable revisions and update services, free (details next slide)</a:t>
             </a:r>
             <a:endParaRPr lang="en-US" sz="1450" dirty="0"/>

</xml_diff>

<commit_message>
Docs sync: pinch-zoom, name chip, dining button into guide feature list + deck inventory (27 items)
</commit_message>
<xml_diff>
--- a/WBYC-Rangefinder-Pitch.pptx
+++ b/WBYC-Rangefinder-Pitch.pptx
@@ -4590,7 +4590,7 @@
         <p:spPr>
           <a:xfrm>
             <a:off x="502920" y="2057400"/>
-            <a:ext cx="3611880" cy="4023360"/>
+            <a:ext cx="3611880" cy="4114800"/>
           </a:xfrm>
           <a:prstGeom prst="rect">
             <a:avLst/>
@@ -4604,13 +4604,13 @@
           <a:p>
             <a:pPr marL="127000" indent="-127000">
               <a:spcAft>
-                <a:spcPts val="700"/>
+                <a:spcPts val="600"/>
               </a:spcAft>
               <a:buSzPct val="100000"/>
               <a:buChar char="•"/>
             </a:pPr>
             <a:r>
-              <a:rPr lang="en-US" sz="1050" dirty="0">
+              <a:rPr lang="en-US" sz="1000" dirty="0">
                 <a:solidFill>
                   <a:srgbClr val="33463C"/>
                 </a:solidFill>
@@ -4620,18 +4620,18 @@
               </a:rPr>
               <a:t>Live GPS front / center / back, 5-fix smoothing</a:t>
             </a:r>
-            <a:endParaRPr lang="en-US" sz="1050" dirty="0"/>
+            <a:endParaRPr lang="en-US" sz="1000" dirty="0"/>
           </a:p>
           <a:p>
             <a:pPr marL="127000" indent="-127000">
               <a:spcAft>
-                <a:spcPts val="700"/>
+                <a:spcPts val="600"/>
               </a:spcAft>
               <a:buSzPct val="100000"/>
               <a:buChar char="•"/>
             </a:pPr>
             <a:r>
-              <a:rPr lang="en-US" sz="1050" dirty="0">
+              <a:rPr lang="en-US" sz="1000" dirty="0">
                 <a:solidFill>
                   <a:srgbClr val="33463C"/>
                 </a:solidFill>
@@ -4641,18 +4641,18 @@
               </a:rPr>
               <a:t>“Plays like” — elevation + live or manual wind</a:t>
             </a:r>
-            <a:endParaRPr lang="en-US" sz="1050" dirty="0"/>
+            <a:endParaRPr lang="en-US" sz="1000" dirty="0"/>
           </a:p>
           <a:p>
             <a:pPr marL="127000" indent="-127000">
               <a:spcAft>
-                <a:spcPts val="700"/>
+                <a:spcPts val="600"/>
               </a:spcAft>
               <a:buSzPct val="100000"/>
               <a:buChar char="•"/>
             </a:pPr>
             <a:r>
-              <a:rPr lang="en-US" sz="1050" dirty="0">
+              <a:rPr lang="en-US" sz="1000" dirty="0">
                 <a:solidFill>
                   <a:srgbClr val="33463C"/>
                 </a:solidFill>
@@ -4662,18 +4662,18 @@
               </a:rPr>
               <a:t>Per-hole wind arrow, oriented to the shot</a:t>
             </a:r>
-            <a:endParaRPr lang="en-US" sz="1050" dirty="0"/>
+            <a:endParaRPr lang="en-US" sz="1000" dirty="0"/>
           </a:p>
           <a:p>
             <a:pPr marL="127000" indent="-127000">
               <a:spcAft>
-                <a:spcPts val="700"/>
+                <a:spcPts val="600"/>
               </a:spcAft>
               <a:buSzPct val="100000"/>
               <a:buChar char="•"/>
             </a:pPr>
             <a:r>
-              <a:rPr lang="en-US" sz="1050" dirty="0">
+              <a:rPr lang="en-US" sz="1000" dirty="0">
                 <a:solidFill>
                   <a:srgbClr val="33463C"/>
                 </a:solidFill>
@@ -4683,18 +4683,18 @@
               </a:rPr>
               <a:t>Hazards &amp; targets: reach/carry to every bunker, water, dogleg</a:t>
             </a:r>
-            <a:endParaRPr lang="en-US" sz="1050" dirty="0"/>
+            <a:endParaRPr lang="en-US" sz="1000" dirty="0"/>
           </a:p>
           <a:p>
             <a:pPr marL="127000" indent="-127000">
               <a:spcAft>
-                <a:spcPts val="700"/>
+                <a:spcPts val="600"/>
               </a:spcAft>
               <a:buSzPct val="100000"/>
               <a:buChar char="•"/>
             </a:pPr>
             <a:r>
-              <a:rPr lang="en-US" sz="1050" dirty="0">
+              <a:rPr lang="en-US" sz="1000" dirty="0">
                 <a:solidFill>
                   <a:srgbClr val="33463C"/>
                 </a:solidFill>
@@ -4704,18 +4704,18 @@
               </a:rPr>
               <a:t>Carry arcs for the selected club ± neighbors</a:t>
             </a:r>
-            <a:endParaRPr lang="en-US" sz="1050" dirty="0"/>
+            <a:endParaRPr lang="en-US" sz="1000" dirty="0"/>
           </a:p>
           <a:p>
             <a:pPr marL="127000" indent="-127000">
               <a:spcAft>
-                <a:spcPts val="700"/>
+                <a:spcPts val="600"/>
               </a:spcAft>
               <a:buSzPct val="100000"/>
               <a:buChar char="•"/>
             </a:pPr>
             <a:r>
-              <a:rPr lang="en-US" sz="1050" dirty="0">
+              <a:rPr lang="en-US" sz="1000" dirty="0">
                 <a:solidFill>
                   <a:srgbClr val="33463C"/>
                 </a:solidFill>
@@ -4725,18 +4725,18 @@
               </a:rPr>
               <a:t>Auto hole detection as you walk</a:t>
             </a:r>
-            <a:endParaRPr lang="en-US" sz="1050" dirty="0"/>
+            <a:endParaRPr lang="en-US" sz="1000" dirty="0"/>
           </a:p>
           <a:p>
             <a:pPr marL="127000" indent="-127000">
               <a:spcAft>
-                <a:spcPts val="700"/>
+                <a:spcPts val="600"/>
               </a:spcAft>
               <a:buSzPct val="100000"/>
               <a:buChar char="•"/>
             </a:pPr>
             <a:r>
-              <a:rPr lang="en-US" sz="1050" dirty="0">
+              <a:rPr lang="en-US" sz="1000" dirty="0">
                 <a:solidFill>
                   <a:srgbClr val="33463C"/>
                 </a:solidFill>
@@ -4746,18 +4746,18 @@
               </a:rPr>
               <a:t>Ball-flight tracer: map arc, side profile, 3D flyover + stats</a:t>
             </a:r>
-            <a:endParaRPr lang="en-US" sz="1050" dirty="0"/>
+            <a:endParaRPr lang="en-US" sz="1000" dirty="0"/>
           </a:p>
           <a:p>
             <a:pPr marL="127000" indent="-127000">
               <a:spcAft>
-                <a:spcPts val="700"/>
+                <a:spcPts val="600"/>
               </a:spcAft>
               <a:buSzPct val="100000"/>
               <a:buChar char="•"/>
             </a:pPr>
             <a:r>
-              <a:rPr lang="en-US" sz="1050" dirty="0">
+              <a:rPr lang="en-US" sz="1000" dirty="0">
                 <a:solidFill>
                   <a:srgbClr val="33463C"/>
                 </a:solidFill>
@@ -4767,18 +4767,18 @@
               </a:rPr>
               <a:t>Pin sheet: tap today’s pin — every number re-keys to it</a:t>
             </a:r>
-            <a:endParaRPr lang="en-US" sz="1050" dirty="0"/>
+            <a:endParaRPr lang="en-US" sz="1000" dirty="0"/>
           </a:p>
           <a:p>
             <a:pPr marL="127000" indent="-127000">
               <a:spcAft>
-                <a:spcPts val="700"/>
+                <a:spcPts val="600"/>
               </a:spcAft>
               <a:buSzPct val="100000"/>
               <a:buChar char="•"/>
             </a:pPr>
             <a:r>
-              <a:rPr lang="en-US" sz="1050" dirty="0">
+              <a:rPr lang="en-US" sz="1000" dirty="0">
                 <a:solidFill>
                   <a:srgbClr val="33463C"/>
                 </a:solidFill>
@@ -4786,81 +4786,20 @@
                 <a:ea typeface="Raleway" pitchFamily="34" charset="-122"/>
                 <a:cs typeface="Raleway" pitchFamily="34" charset="-120"/>
               </a:rPr>
-              <a:t>Tournament switch: one tap to legal raw yardages</a:t>
-            </a:r>
-            <a:endParaRPr lang="en-US" sz="1050" dirty="0"/>
-          </a:p>
-        </p:txBody>
-      </p:sp>
-      <p:sp>
-        <p:nvSpPr>
-          <p:cNvPr id="6" name="Text 4"/>
-          <p:cNvSpPr/>
-          <p:nvPr/>
-        </p:nvSpPr>
-        <p:spPr>
-          <a:xfrm>
-            <a:off x="4325112" y="1645920"/>
-            <a:ext cx="3566160" cy="320040"/>
-          </a:xfrm>
-          <a:prstGeom prst="rect">
-            <a:avLst/>
-          </a:prstGeom>
-          <a:noFill/>
-          <a:ln/>
-        </p:spPr>
-        <p:txBody>
-          <a:bodyPr wrap="square" lIns="0" tIns="0" rIns="0" bIns="0" rtlCol="0" anchor="ctr"/>
-          <a:lstStyle/>
-          <a:p>
-            <a:pPr indent="0" marL="0">
-              <a:buNone/>
-            </a:pPr>
-            <a:r>
-              <a:rPr lang="en-US" sz="1200" b="1" spc="200" kern="0" dirty="0">
-                <a:solidFill>
-                  <a:srgbClr val="1E7A4A"/>
-                </a:solidFill>
-                <a:latin typeface="Raleway" pitchFamily="34" charset="0"/>
-                <a:ea typeface="Raleway" pitchFamily="34" charset="-122"/>
-                <a:cs typeface="Raleway" pitchFamily="34" charset="-120"/>
-              </a:rPr>
-              <a:t>SCORING &amp; YOUR GAME</a:t>
-            </a:r>
-            <a:endParaRPr lang="en-US" sz="1200" dirty="0"/>
-          </a:p>
-        </p:txBody>
-      </p:sp>
-      <p:sp>
-        <p:nvSpPr>
-          <p:cNvPr id="7" name="Text 5"/>
-          <p:cNvSpPr/>
-          <p:nvPr/>
-        </p:nvSpPr>
-        <p:spPr>
-          <a:xfrm>
-            <a:off x="4325112" y="2057400"/>
-            <a:ext cx="3611880" cy="4023360"/>
-          </a:xfrm>
-          <a:prstGeom prst="rect">
-            <a:avLst/>
-          </a:prstGeom>
-          <a:noFill/>
-          <a:ln/>
-        </p:spPr>
-        <p:txBody>
-          <a:bodyPr wrap="square" lIns="0" tIns="0" rIns="0" bIns="0" rtlCol="0" anchor="t"/>
-          <a:lstStyle/>
+              <a:t>Pinch-zoom hole map, up to 8×</a:t>
+            </a:r>
+            <a:endParaRPr lang="en-US" sz="1000" dirty="0"/>
+          </a:p>
           <a:p>
             <a:pPr marL="127000" indent="-127000">
               <a:spcAft>
-                <a:spcPts val="700"/>
+                <a:spcPts val="600"/>
               </a:spcAft>
               <a:buSzPct val="100000"/>
               <a:buChar char="•"/>
             </a:pPr>
             <a:r>
-              <a:rPr lang="en-US" sz="1050" dirty="0">
+              <a:rPr lang="en-US" sz="1000" dirty="0">
                 <a:solidFill>
                   <a:srgbClr val="33463C"/>
                 </a:solidFill>
@@ -4868,20 +4807,81 @@
                 <a:ea typeface="Raleway" pitchFamily="34" charset="-122"/>
                 <a:cs typeface="Raleway" pitchFamily="34" charset="-120"/>
               </a:rPr>
-              <a:t>Running strokes / putts / fairways strip</a:t>
-            </a:r>
-            <a:endParaRPr lang="en-US" sz="1050" dirty="0"/>
-          </a:p>
+              <a:t>Tournament switch: one tap to legal raw yardages</a:t>
+            </a:r>
+            <a:endParaRPr lang="en-US" sz="1000" dirty="0"/>
+          </a:p>
+        </p:txBody>
+      </p:sp>
+      <p:sp>
+        <p:nvSpPr>
+          <p:cNvPr id="6" name="Text 4"/>
+          <p:cNvSpPr/>
+          <p:nvPr/>
+        </p:nvSpPr>
+        <p:spPr>
+          <a:xfrm>
+            <a:off x="4325112" y="1645920"/>
+            <a:ext cx="3566160" cy="320040"/>
+          </a:xfrm>
+          <a:prstGeom prst="rect">
+            <a:avLst/>
+          </a:prstGeom>
+          <a:noFill/>
+          <a:ln/>
+        </p:spPr>
+        <p:txBody>
+          <a:bodyPr wrap="square" lIns="0" tIns="0" rIns="0" bIns="0" rtlCol="0" anchor="ctr"/>
+          <a:lstStyle/>
+          <a:p>
+            <a:pPr indent="0" marL="0">
+              <a:buNone/>
+            </a:pPr>
+            <a:r>
+              <a:rPr lang="en-US" sz="1200" b="1" spc="200" kern="0" dirty="0">
+                <a:solidFill>
+                  <a:srgbClr val="1E7A4A"/>
+                </a:solidFill>
+                <a:latin typeface="Raleway" pitchFamily="34" charset="0"/>
+                <a:ea typeface="Raleway" pitchFamily="34" charset="-122"/>
+                <a:cs typeface="Raleway" pitchFamily="34" charset="-120"/>
+              </a:rPr>
+              <a:t>SCORING &amp; YOUR GAME</a:t>
+            </a:r>
+            <a:endParaRPr lang="en-US" sz="1200" dirty="0"/>
+          </a:p>
+        </p:txBody>
+      </p:sp>
+      <p:sp>
+        <p:nvSpPr>
+          <p:cNvPr id="7" name="Text 5"/>
+          <p:cNvSpPr/>
+          <p:nvPr/>
+        </p:nvSpPr>
+        <p:spPr>
+          <a:xfrm>
+            <a:off x="4325112" y="2057400"/>
+            <a:ext cx="3611880" cy="4114800"/>
+          </a:xfrm>
+          <a:prstGeom prst="rect">
+            <a:avLst/>
+          </a:prstGeom>
+          <a:noFill/>
+          <a:ln/>
+        </p:spPr>
+        <p:txBody>
+          <a:bodyPr wrap="square" lIns="0" tIns="0" rIns="0" bIns="0" rtlCol="0" anchor="t"/>
+          <a:lstStyle/>
           <a:p>
             <a:pPr marL="127000" indent="-127000">
               <a:spcAft>
-                <a:spcPts val="700"/>
+                <a:spcPts val="600"/>
               </a:spcAft>
               <a:buSzPct val="100000"/>
               <a:buChar char="•"/>
             </a:pPr>
             <a:r>
-              <a:rPr lang="en-US" sz="1050" dirty="0">
+              <a:rPr lang="en-US" sz="1000" dirty="0">
                 <a:solidFill>
                   <a:srgbClr val="33463C"/>
                 </a:solidFill>
@@ -4889,20 +4889,20 @@
                 <a:ea typeface="Raleway" pitchFamily="34" charset="-122"/>
                 <a:cs typeface="Raleway" pitchFamily="34" charset="-120"/>
               </a:rPr>
-              <a:t>Full 18-hole card with OUT/IN/total &amp; GIR</a:t>
-            </a:r>
-            <a:endParaRPr lang="en-US" sz="1050" dirty="0"/>
+              <a:t>Running strokes / putts / fairways strip</a:t>
+            </a:r>
+            <a:endParaRPr lang="en-US" sz="1000" dirty="0"/>
           </a:p>
           <a:p>
             <a:pPr marL="127000" indent="-127000">
               <a:spcAft>
-                <a:spcPts val="700"/>
+                <a:spcPts val="600"/>
               </a:spcAft>
               <a:buSzPct val="100000"/>
               <a:buChar char="•"/>
             </a:pPr>
             <a:r>
-              <a:rPr lang="en-US" sz="1050" dirty="0">
+              <a:rPr lang="en-US" sz="1000" dirty="0">
                 <a:solidFill>
                   <a:srgbClr val="33463C"/>
                 </a:solidFill>
@@ -4910,20 +4910,20 @@
                 <a:ea typeface="Raleway" pitchFamily="34" charset="-122"/>
                 <a:cs typeface="Raleway" pitchFamily="34" charset="-120"/>
               </a:rPr>
-              <a:t>Round history: trend line, bests, last-5 averages</a:t>
-            </a:r>
-            <a:endParaRPr lang="en-US" sz="1050" dirty="0"/>
+              <a:t>Full 18-hole card with OUT/IN/total &amp; GIR</a:t>
+            </a:r>
+            <a:endParaRPr lang="en-US" sz="1000" dirty="0"/>
           </a:p>
           <a:p>
             <a:pPr marL="127000" indent="-127000">
               <a:spcAft>
-                <a:spcPts val="700"/>
+                <a:spcPts val="600"/>
               </a:spcAft>
               <a:buSzPct val="100000"/>
               <a:buChar char="•"/>
             </a:pPr>
             <a:r>
-              <a:rPr lang="en-US" sz="1050" dirty="0">
+              <a:rPr lang="en-US" sz="1000" dirty="0">
                 <a:solidFill>
                   <a:srgbClr val="33463C"/>
                 </a:solidFill>
@@ -4931,20 +4931,20 @@
                 <a:ea typeface="Raleway" pitchFamily="34" charset="-122"/>
                 <a:cs typeface="Raleway" pitchFamily="34" charset="-120"/>
               </a:rPr>
-              <a:t>Club distances learned from marked shots</a:t>
-            </a:r>
-            <a:endParaRPr lang="en-US" sz="1050" dirty="0"/>
+              <a:t>Round history: trend line, bests, last-5 averages</a:t>
+            </a:r>
+            <a:endParaRPr lang="en-US" sz="1000" dirty="0"/>
           </a:p>
           <a:p>
             <a:pPr marL="127000" indent="-127000">
               <a:spcAft>
-                <a:spcPts val="700"/>
+                <a:spcPts val="600"/>
               </a:spcAft>
               <a:buSzPct val="100000"/>
               <a:buChar char="•"/>
             </a:pPr>
             <a:r>
-              <a:rPr lang="en-US" sz="1050" dirty="0">
+              <a:rPr lang="en-US" sz="1000" dirty="0">
                 <a:solidFill>
                   <a:srgbClr val="33463C"/>
                 </a:solidFill>
@@ -4952,20 +4952,20 @@
                 <a:ea typeface="Raleway" pitchFamily="34" charset="-122"/>
                 <a:cs typeface="Raleway" pitchFamily="34" charset="-120"/>
               </a:rPr>
-              <a:t>Club hints inside the plays-like readout</a:t>
-            </a:r>
-            <a:endParaRPr lang="en-US" sz="1050" dirty="0"/>
+              <a:t>Club distances learned from marked shots</a:t>
+            </a:r>
+            <a:endParaRPr lang="en-US" sz="1000" dirty="0"/>
           </a:p>
           <a:p>
             <a:pPr marL="127000" indent="-127000">
               <a:spcAft>
-                <a:spcPts val="700"/>
+                <a:spcPts val="600"/>
               </a:spcAft>
               <a:buSzPct val="100000"/>
               <a:buChar char="•"/>
             </a:pPr>
             <a:r>
-              <a:rPr lang="en-US" sz="1050" dirty="0">
+              <a:rPr lang="en-US" sz="1000" dirty="0">
                 <a:solidFill>
                   <a:srgbClr val="33463C"/>
                 </a:solidFill>
@@ -4973,20 +4973,20 @@
                 <a:ea typeface="Raleway" pitchFamily="34" charset="-122"/>
                 <a:cs typeface="Raleway" pitchFamily="34" charset="-120"/>
               </a:rPr>
-              <a:t>Shot map: numbered dots + trail per hole</a:t>
-            </a:r>
-            <a:endParaRPr lang="en-US" sz="1050" dirty="0"/>
+              <a:t>Club hints inside the plays-like readout</a:t>
+            </a:r>
+            <a:endParaRPr lang="en-US" sz="1000" dirty="0"/>
           </a:p>
           <a:p>
             <a:pPr marL="127000" indent="-127000">
               <a:spcAft>
-                <a:spcPts val="700"/>
+                <a:spcPts val="600"/>
               </a:spcAft>
               <a:buSzPct val="100000"/>
               <a:buChar char="•"/>
             </a:pPr>
             <a:r>
-              <a:rPr lang="en-US" sz="1050" dirty="0">
+              <a:rPr lang="en-US" sz="1000" dirty="0">
                 <a:solidFill>
                   <a:srgbClr val="33463C"/>
                 </a:solidFill>
@@ -4994,20 +4994,20 @@
                 <a:ea typeface="Raleway" pitchFamily="34" charset="-122"/>
                 <a:cs typeface="Raleway" pitchFamily="34" charset="-120"/>
               </a:rPr>
-              <a:t>One-tap GHIN posting helper</a:t>
-            </a:r>
-            <a:endParaRPr lang="en-US" sz="1050" dirty="0"/>
+              <a:t>Shot map: numbered dots + trail per hole</a:t>
+            </a:r>
+            <a:endParaRPr lang="en-US" sz="1000" dirty="0"/>
           </a:p>
           <a:p>
             <a:pPr marL="127000" indent="-127000">
               <a:spcAft>
-                <a:spcPts val="700"/>
+                <a:spcPts val="600"/>
               </a:spcAft>
               <a:buSzPct val="100000"/>
               <a:buChar char="•"/>
             </a:pPr>
             <a:r>
-              <a:rPr lang="en-US" sz="1050" dirty="0">
+              <a:rPr lang="en-US" sz="1000" dirty="0">
                 <a:solidFill>
                   <a:srgbClr val="33463C"/>
                 </a:solidFill>
@@ -5015,81 +5015,20 @@
                 <a:ea typeface="Raleway" pitchFamily="34" charset="-122"/>
                 <a:cs typeface="Raleway" pitchFamily="34" charset="-120"/>
               </a:rPr>
-              <a:t>Women’s par handled automatically from the Red tees</a:t>
-            </a:r>
-            <a:endParaRPr lang="en-US" sz="1050" dirty="0"/>
-          </a:p>
-        </p:txBody>
-      </p:sp>
-      <p:sp>
-        <p:nvSpPr>
-          <p:cNvPr id="8" name="Text 6"/>
-          <p:cNvSpPr/>
-          <p:nvPr/>
-        </p:nvSpPr>
-        <p:spPr>
-          <a:xfrm>
-            <a:off x="8147304" y="1645920"/>
-            <a:ext cx="3566160" cy="320040"/>
-          </a:xfrm>
-          <a:prstGeom prst="rect">
-            <a:avLst/>
-          </a:prstGeom>
-          <a:noFill/>
-          <a:ln/>
-        </p:spPr>
-        <p:txBody>
-          <a:bodyPr wrap="square" lIns="0" tIns="0" rIns="0" bIns="0" rtlCol="0" anchor="ctr"/>
-          <a:lstStyle/>
-          <a:p>
-            <a:pPr indent="0" marL="0">
-              <a:buNone/>
-            </a:pPr>
-            <a:r>
-              <a:rPr lang="en-US" sz="1200" b="1" spc="200" kern="0" dirty="0">
-                <a:solidFill>
-                  <a:srgbClr val="F000C2"/>
-                </a:solidFill>
-                <a:latin typeface="Raleway" pitchFamily="34" charset="0"/>
-                <a:ea typeface="Raleway" pitchFamily="34" charset="-122"/>
-                <a:cs typeface="Raleway" pitchFamily="34" charset="-120"/>
-              </a:rPr>
-              <a:t>CRAFT &amp; PLATFORM</a:t>
-            </a:r>
-            <a:endParaRPr lang="en-US" sz="1200" dirty="0"/>
-          </a:p>
-        </p:txBody>
-      </p:sp>
-      <p:sp>
-        <p:nvSpPr>
-          <p:cNvPr id="9" name="Text 7"/>
-          <p:cNvSpPr/>
-          <p:nvPr/>
-        </p:nvSpPr>
-        <p:spPr>
-          <a:xfrm>
-            <a:off x="8147304" y="2057400"/>
-            <a:ext cx="3611880" cy="4023360"/>
-          </a:xfrm>
-          <a:prstGeom prst="rect">
-            <a:avLst/>
-          </a:prstGeom>
-          <a:noFill/>
-          <a:ln/>
-        </p:spPr>
-        <p:txBody>
-          <a:bodyPr wrap="square" lIns="0" tIns="0" rIns="0" bIns="0" rtlCol="0" anchor="t"/>
-          <a:lstStyle/>
+              <a:t>One-tap GHIN posting helper</a:t>
+            </a:r>
+            <a:endParaRPr lang="en-US" sz="1000" dirty="0"/>
+          </a:p>
           <a:p>
             <a:pPr marL="127000" indent="-127000">
               <a:spcAft>
-                <a:spcPts val="700"/>
+                <a:spcPts val="600"/>
               </a:spcAft>
               <a:buSzPct val="100000"/>
               <a:buChar char="•"/>
             </a:pPr>
             <a:r>
-              <a:rPr lang="en-US" sz="1050" dirty="0">
+              <a:rPr lang="en-US" sz="1000" dirty="0">
                 <a:solidFill>
                   <a:srgbClr val="33463C"/>
                 </a:solidFill>
@@ -5097,20 +5036,20 @@
                 <a:ea typeface="Raleway" pitchFamily="34" charset="-122"/>
                 <a:cs typeface="Raleway" pitchFamily="34" charset="-120"/>
               </a:rPr>
-              <a:t>2-ft contours; fall-line arrows on every green</a:t>
-            </a:r>
-            <a:endParaRPr lang="en-US" sz="1050" dirty="0"/>
+              <a:t>Your name signs the card &amp; GHIN posts (device-only)</a:t>
+            </a:r>
+            <a:endParaRPr lang="en-US" sz="1000" dirty="0"/>
           </a:p>
           <a:p>
             <a:pPr marL="127000" indent="-127000">
               <a:spcAft>
-                <a:spcPts val="700"/>
+                <a:spcPts val="600"/>
               </a:spcAft>
               <a:buSzPct val="100000"/>
               <a:buChar char="•"/>
             </a:pPr>
             <a:r>
-              <a:rPr lang="en-US" sz="1050" dirty="0">
+              <a:rPr lang="en-US" sz="1000" dirty="0">
                 <a:solidFill>
                   <a:srgbClr val="33463C"/>
                 </a:solidFill>
@@ -5118,20 +5057,81 @@
                 <a:ea typeface="Raleway" pitchFamily="34" charset="-122"/>
                 <a:cs typeface="Raleway" pitchFamily="34" charset="-120"/>
               </a:rPr>
-              <a:t>Hypsometric terrain tint with hillshading</a:t>
-            </a:r>
-            <a:endParaRPr lang="en-US" sz="1050" dirty="0"/>
-          </a:p>
+              <a:t>All five tee sets, incl. the new Greens, correct pars &amp; handicaps</a:t>
+            </a:r>
+            <a:endParaRPr lang="en-US" sz="1000" dirty="0"/>
+          </a:p>
+        </p:txBody>
+      </p:sp>
+      <p:sp>
+        <p:nvSpPr>
+          <p:cNvPr id="8" name="Text 6"/>
+          <p:cNvSpPr/>
+          <p:nvPr/>
+        </p:nvSpPr>
+        <p:spPr>
+          <a:xfrm>
+            <a:off x="8147304" y="1645920"/>
+            <a:ext cx="3566160" cy="320040"/>
+          </a:xfrm>
+          <a:prstGeom prst="rect">
+            <a:avLst/>
+          </a:prstGeom>
+          <a:noFill/>
+          <a:ln/>
+        </p:spPr>
+        <p:txBody>
+          <a:bodyPr wrap="square" lIns="0" tIns="0" rIns="0" bIns="0" rtlCol="0" anchor="ctr"/>
+          <a:lstStyle/>
+          <a:p>
+            <a:pPr indent="0" marL="0">
+              <a:buNone/>
+            </a:pPr>
+            <a:r>
+              <a:rPr lang="en-US" sz="1200" b="1" spc="200" kern="0" dirty="0">
+                <a:solidFill>
+                  <a:srgbClr val="F000C2"/>
+                </a:solidFill>
+                <a:latin typeface="Raleway" pitchFamily="34" charset="0"/>
+                <a:ea typeface="Raleway" pitchFamily="34" charset="-122"/>
+                <a:cs typeface="Raleway" pitchFamily="34" charset="-120"/>
+              </a:rPr>
+              <a:t>CRAFT &amp; PLATFORM</a:t>
+            </a:r>
+            <a:endParaRPr lang="en-US" sz="1200" dirty="0"/>
+          </a:p>
+        </p:txBody>
+      </p:sp>
+      <p:sp>
+        <p:nvSpPr>
+          <p:cNvPr id="9" name="Text 7"/>
+          <p:cNvSpPr/>
+          <p:nvPr/>
+        </p:nvSpPr>
+        <p:spPr>
+          <a:xfrm>
+            <a:off x="8147304" y="2057400"/>
+            <a:ext cx="3611880" cy="4114800"/>
+          </a:xfrm>
+          <a:prstGeom prst="rect">
+            <a:avLst/>
+          </a:prstGeom>
+          <a:noFill/>
+          <a:ln/>
+        </p:spPr>
+        <p:txBody>
+          <a:bodyPr wrap="square" lIns="0" tIns="0" rIns="0" bIns="0" rtlCol="0" anchor="t"/>
+          <a:lstStyle/>
           <a:p>
             <a:pPr marL="127000" indent="-127000">
               <a:spcAft>
-                <a:spcPts val="700"/>
+                <a:spcPts val="600"/>
               </a:spcAft>
               <a:buSzPct val="100000"/>
               <a:buChar char="•"/>
             </a:pPr>
             <a:r>
-              <a:rPr lang="en-US" sz="1050" dirty="0">
+              <a:rPr lang="en-US" sz="1000" dirty="0">
                 <a:solidFill>
                   <a:srgbClr val="33463C"/>
                 </a:solidFill>
@@ -5139,20 +5139,20 @@
                 <a:ea typeface="Raleway" pitchFamily="34" charset="-122"/>
                 <a:cs typeface="Raleway" pitchFamily="34" charset="-120"/>
               </a:rPr>
-              <a:t>NAIP aerial layer (SAT), geo-aligned</a:t>
-            </a:r>
-            <a:endParaRPr lang="en-US" sz="1050" dirty="0"/>
+              <a:t>2-ft contours; fall-line arrows on every green</a:t>
+            </a:r>
+            <a:endParaRPr lang="en-US" sz="1000" dirty="0"/>
           </a:p>
           <a:p>
             <a:pPr marL="127000" indent="-127000">
               <a:spcAft>
-                <a:spcPts val="700"/>
+                <a:spcPts val="600"/>
               </a:spcAft>
               <a:buSzPct val="100000"/>
               <a:buChar char="•"/>
             </a:pPr>
             <a:r>
-              <a:rPr lang="en-US" sz="1050" dirty="0">
+              <a:rPr lang="en-US" sz="1000" dirty="0">
                 <a:solidFill>
                   <a:srgbClr val="33463C"/>
                 </a:solidFill>
@@ -5160,20 +5160,20 @@
                 <a:ea typeface="Raleway" pitchFamily="34" charset="-122"/>
                 <a:cs typeface="Raleway" pitchFamily="34" charset="-120"/>
               </a:rPr>
-              <a:t>3D terrain with adjustable exaggeration</a:t>
-            </a:r>
-            <a:endParaRPr lang="en-US" sz="1050" dirty="0"/>
+              <a:t>Hypsometric terrain tint with hillshading</a:t>
+            </a:r>
+            <a:endParaRPr lang="en-US" sz="1000" dirty="0"/>
           </a:p>
           <a:p>
             <a:pPr marL="127000" indent="-127000">
               <a:spcAft>
-                <a:spcPts val="700"/>
+                <a:spcPts val="600"/>
               </a:spcAft>
               <a:buSzPct val="100000"/>
               <a:buChar char="•"/>
             </a:pPr>
             <a:r>
-              <a:rPr lang="en-US" sz="1050" dirty="0">
+              <a:rPr lang="en-US" sz="1000" dirty="0">
                 <a:solidFill>
                   <a:srgbClr val="33463C"/>
                 </a:solidFill>
@@ -5181,20 +5181,20 @@
                 <a:ea typeface="Raleway" pitchFamily="34" charset="-122"/>
                 <a:cs typeface="Raleway" pitchFamily="34" charset="-120"/>
               </a:rPr>
-              <a:t>Three themes, incl. a bright-sunlight mode</a:t>
-            </a:r>
-            <a:endParaRPr lang="en-US" sz="1050" dirty="0"/>
+              <a:t>NAIP aerial layer (SAT), geo-aligned</a:t>
+            </a:r>
+            <a:endParaRPr lang="en-US" sz="1000" dirty="0"/>
           </a:p>
           <a:p>
             <a:pPr marL="127000" indent="-127000">
               <a:spcAft>
-                <a:spcPts val="700"/>
+                <a:spcPts val="600"/>
               </a:spcAft>
               <a:buSzPct val="100000"/>
               <a:buChar char="•"/>
             </a:pPr>
             <a:r>
-              <a:rPr lang="en-US" sz="1050" dirty="0">
+              <a:rPr lang="en-US" sz="1000" dirty="0">
                 <a:solidFill>
                   <a:srgbClr val="33463C"/>
                 </a:solidFill>
@@ -5202,20 +5202,20 @@
                 <a:ea typeface="Raleway" pitchFamily="34" charset="-122"/>
                 <a:cs typeface="Raleway" pitchFamily="34" charset="-120"/>
               </a:rPr>
-              <a:t>Offline PWA: home-screen install, wake lock</a:t>
-            </a:r>
-            <a:endParaRPr lang="en-US" sz="1050" dirty="0"/>
+              <a:t>3D terrain with adjustable exaggeration</a:t>
+            </a:r>
+            <a:endParaRPr lang="en-US" sz="1000" dirty="0"/>
           </a:p>
           <a:p>
             <a:pPr marL="127000" indent="-127000">
               <a:spcAft>
-                <a:spcPts val="700"/>
+                <a:spcPts val="600"/>
               </a:spcAft>
               <a:buSzPct val="100000"/>
               <a:buChar char="•"/>
             </a:pPr>
             <a:r>
-              <a:rPr lang="en-US" sz="1050" dirty="0">
+              <a:rPr lang="en-US" sz="1000" dirty="0">
                 <a:solidFill>
                   <a:srgbClr val="33463C"/>
                 </a:solidFill>
@@ -5223,20 +5223,20 @@
                 <a:ea typeface="Raleway" pitchFamily="34" charset="-122"/>
                 <a:cs typeface="Raleway" pitchFamily="34" charset="-120"/>
               </a:rPr>
-              <a:t>No accounts, ads, or data collection</a:t>
-            </a:r>
-            <a:endParaRPr lang="en-US" sz="1050" dirty="0"/>
+              <a:t>Three themes, incl. a bright-sunlight mode</a:t>
+            </a:r>
+            <a:endParaRPr lang="en-US" sz="1000" dirty="0"/>
           </a:p>
           <a:p>
             <a:pPr marL="127000" indent="-127000">
               <a:spcAft>
-                <a:spcPts val="700"/>
+                <a:spcPts val="600"/>
               </a:spcAft>
               <a:buSzPct val="100000"/>
               <a:buChar char="•"/>
             </a:pPr>
             <a:r>
-              <a:rPr lang="en-US" sz="1050" dirty="0">
+              <a:rPr lang="en-US" sz="1000" dirty="0">
                 <a:solidFill>
                   <a:srgbClr val="33463C"/>
                 </a:solidFill>
@@ -5244,9 +5244,72 @@
                 <a:ea typeface="Raleway" pitchFamily="34" charset="-122"/>
                 <a:cs typeface="Raleway" pitchFamily="34" charset="-120"/>
               </a:rPr>
+              <a:t>Offline PWA: home-screen install, wake lock</a:t>
+            </a:r>
+            <a:endParaRPr lang="en-US" sz="1000" dirty="0"/>
+          </a:p>
+          <a:p>
+            <a:pPr marL="127000" indent="-127000">
+              <a:spcAft>
+                <a:spcPts val="600"/>
+              </a:spcAft>
+              <a:buSzPct val="100000"/>
+              <a:buChar char="•"/>
+            </a:pPr>
+            <a:r>
+              <a:rPr lang="en-US" sz="1000" dirty="0">
+                <a:solidFill>
+                  <a:srgbClr val="33463C"/>
+                </a:solidFill>
+                <a:latin typeface="Raleway" pitchFamily="34" charset="0"/>
+                <a:ea typeface="Raleway" pitchFamily="34" charset="-122"/>
+                <a:cs typeface="Raleway" pitchFamily="34" charset="-120"/>
+              </a:rPr>
+              <a:t>No accounts, ads, or data collection</a:t>
+            </a:r>
+            <a:endParaRPr lang="en-US" sz="1000" dirty="0"/>
+          </a:p>
+          <a:p>
+            <a:pPr marL="127000" indent="-127000">
+              <a:spcAft>
+                <a:spcPts val="600"/>
+              </a:spcAft>
+              <a:buSzPct val="100000"/>
+              <a:buChar char="•"/>
+            </a:pPr>
+            <a:r>
+              <a:rPr lang="en-US" sz="1000" dirty="0">
+                <a:solidFill>
+                  <a:srgbClr val="33463C"/>
+                </a:solidFill>
+                <a:latin typeface="Raleway" pitchFamily="34" charset="0"/>
+                <a:ea typeface="Raleway" pitchFamily="34" charset="-122"/>
+                <a:cs typeface="Raleway" pitchFamily="34" charset="-120"/>
+              </a:rPr>
+              <a:t>One-tap call to the Golf House bar/dining</a:t>
+            </a:r>
+            <a:endParaRPr lang="en-US" sz="1000" dirty="0"/>
+          </a:p>
+          <a:p>
+            <a:pPr marL="127000" indent="-127000">
+              <a:spcAft>
+                <a:spcPts val="600"/>
+              </a:spcAft>
+              <a:buSzPct val="100000"/>
+              <a:buChar char="•"/>
+            </a:pPr>
+            <a:r>
+              <a:rPr lang="en-US" sz="1000" dirty="0">
+                <a:solidFill>
+                  <a:srgbClr val="33463C"/>
+                </a:solidFill>
+                <a:latin typeface="Raleway" pitchFamily="34" charset="0"/>
+                <a:ea typeface="Raleway" pitchFamily="34" charset="-122"/>
+                <a:cs typeface="Raleway" pitchFamily="34" charset="-120"/>
+              </a:rPr>
               <a:t>A little hidden whimsy for those who explore</a:t>
             </a:r>
-            <a:endParaRPr lang="en-US" sz="1050" dirty="0"/>
+            <a:endParaRPr lang="en-US" sz="1000" dirty="0"/>
           </a:p>
         </p:txBody>
       </p:sp>

</xml_diff>

<commit_message>
Docs: phone install flow (Safari share-button steps, location fix, 2-launch update note) in guide; 40-second adoption line on the members-pay slide
</commit_message>
<xml_diff>
--- a/WBYC-Rangefinder-Pitch.pptx
+++ b/WBYC-Rangefinder-Pitch.pptx
@@ -10223,6 +10223,23 @@
             </a:r>
             <a:endParaRPr lang="en-US" sz="2600" dirty="0"/>
           </a:p>
+          <a:p>
+            <a:pPr indent="0" marL="0">
+              <a:buNone/>
+            </a:pPr>
+            <a:r>
+              <a:rPr lang="en-US" sz="1300" i="1" dirty="0">
+                <a:solidFill>
+                  <a:srgbClr val="FFA5EB"/>
+                </a:solidFill>
+                <a:latin typeface="Raleway" pitchFamily="34" charset="0"/>
+                <a:ea typeface="Raleway" pitchFamily="34" charset="-122"/>
+                <a:cs typeface="Raleway" pitchFamily="34" charset="-120"/>
+              </a:rPr>
+              <a:t>Adoption ask: 40 seconds. Open the link → allow location → Add to Home Screen. No App Store, no account, no update chores.</a:t>
+            </a:r>
+            <a:endParaRPr lang="en-US" sz="2600" dirty="0"/>
+          </a:p>
         </p:txBody>
       </p:sp>
       <p:sp>

</xml_diff>